<commit_message>
Modification du COMMIT 10
</commit_message>
<xml_diff>
--- a/docs/DIAO_Aissatou_Presentation.pptx
+++ b/docs/DIAO_Aissatou_Presentation.pptx
@@ -12,10 +12,13 @@
     <p:sldId id="260" r:id="rId6"/>
     <p:sldId id="262" r:id="rId7"/>
     <p:sldId id="261" r:id="rId8"/>
-    <p:sldId id="263" r:id="rId9"/>
-    <p:sldId id="264" r:id="rId10"/>
-    <p:sldId id="265" r:id="rId11"/>
-    <p:sldId id="266" r:id="rId12"/>
+    <p:sldId id="268" r:id="rId9"/>
+    <p:sldId id="269" r:id="rId10"/>
+    <p:sldId id="263" r:id="rId11"/>
+    <p:sldId id="264" r:id="rId12"/>
+    <p:sldId id="265" r:id="rId13"/>
+    <p:sldId id="266" r:id="rId14"/>
+    <p:sldId id="267" r:id="rId15"/>
   </p:sldIdLst>
   <p:sldSz cx="12192000" cy="6858000"/>
   <p:notesSz cx="6858000" cy="9144000"/>
@@ -114,6 +117,11 @@
       </a:defRPr>
     </a:lvl9pPr>
   </p:defaultTextStyle>
+  <p:extLst>
+    <p:ext uri="{EFAFB233-063F-42B5-8137-9DF3F51BA10A}">
+      <p15:sldGuideLst xmlns:p15="http://schemas.microsoft.com/office/powerpoint/2012/main"/>
+    </p:ext>
+  </p:extLst>
 </p:presentation>
 </file>
 
@@ -256,7 +264,7 @@
           <a:p>
             <a:fld id="{EBB3AEE8-3EC3-44A2-86E6-306757BFC25E}" type="datetimeFigureOut">
               <a:rPr lang="fr-FR" smtClean="0"/>
-              <a:t>17/06/2026</a:t>
+              <a:t>23/06/2026</a:t>
             </a:fld>
             <a:endParaRPr lang="fr-FR"/>
           </a:p>
@@ -467,7 +475,7 @@
           <a:p>
             <a:fld id="{EBB3AEE8-3EC3-44A2-86E6-306757BFC25E}" type="datetimeFigureOut">
               <a:rPr lang="fr-FR" smtClean="0"/>
-              <a:t>17/06/2026</a:t>
+              <a:t>23/06/2026</a:t>
             </a:fld>
             <a:endParaRPr lang="fr-FR"/>
           </a:p>
@@ -682,7 +690,7 @@
           <a:p>
             <a:fld id="{EBB3AEE8-3EC3-44A2-86E6-306757BFC25E}" type="datetimeFigureOut">
               <a:rPr lang="fr-FR" smtClean="0"/>
-              <a:t>17/06/2026</a:t>
+              <a:t>23/06/2026</a:t>
             </a:fld>
             <a:endParaRPr lang="fr-FR"/>
           </a:p>
@@ -883,7 +891,7 @@
           <a:p>
             <a:fld id="{EBB3AEE8-3EC3-44A2-86E6-306757BFC25E}" type="datetimeFigureOut">
               <a:rPr lang="fr-FR" smtClean="0"/>
-              <a:t>17/06/2026</a:t>
+              <a:t>23/06/2026</a:t>
             </a:fld>
             <a:endParaRPr lang="fr-FR"/>
           </a:p>
@@ -1162,7 +1170,7 @@
           <a:p>
             <a:fld id="{EBB3AEE8-3EC3-44A2-86E6-306757BFC25E}" type="datetimeFigureOut">
               <a:rPr lang="fr-FR" smtClean="0"/>
-              <a:t>17/06/2026</a:t>
+              <a:t>23/06/2026</a:t>
             </a:fld>
             <a:endParaRPr lang="fr-FR"/>
           </a:p>
@@ -1430,7 +1438,7 @@
           <a:p>
             <a:fld id="{EBB3AEE8-3EC3-44A2-86E6-306757BFC25E}" type="datetimeFigureOut">
               <a:rPr lang="fr-FR" smtClean="0"/>
-              <a:t>17/06/2026</a:t>
+              <a:t>23/06/2026</a:t>
             </a:fld>
             <a:endParaRPr lang="fr-FR"/>
           </a:p>
@@ -1846,7 +1854,7 @@
           <a:p>
             <a:fld id="{EBB3AEE8-3EC3-44A2-86E6-306757BFC25E}" type="datetimeFigureOut">
               <a:rPr lang="fr-FR" smtClean="0"/>
-              <a:t>17/06/2026</a:t>
+              <a:t>23/06/2026</a:t>
             </a:fld>
             <a:endParaRPr lang="fr-FR"/>
           </a:p>
@@ -1995,7 +2003,7 @@
           <a:p>
             <a:fld id="{EBB3AEE8-3EC3-44A2-86E6-306757BFC25E}" type="datetimeFigureOut">
               <a:rPr lang="fr-FR" smtClean="0"/>
-              <a:t>17/06/2026</a:t>
+              <a:t>23/06/2026</a:t>
             </a:fld>
             <a:endParaRPr lang="fr-FR"/>
           </a:p>
@@ -2121,7 +2129,7 @@
           <a:p>
             <a:fld id="{EBB3AEE8-3EC3-44A2-86E6-306757BFC25E}" type="datetimeFigureOut">
               <a:rPr lang="fr-FR" smtClean="0"/>
-              <a:t>17/06/2026</a:t>
+              <a:t>23/06/2026</a:t>
             </a:fld>
             <a:endParaRPr lang="fr-FR"/>
           </a:p>
@@ -2372,7 +2380,7 @@
           <a:p>
             <a:fld id="{EBB3AEE8-3EC3-44A2-86E6-306757BFC25E}" type="datetimeFigureOut">
               <a:rPr lang="fr-FR" smtClean="0"/>
-              <a:t>17/06/2026</a:t>
+              <a:t>23/06/2026</a:t>
             </a:fld>
             <a:endParaRPr lang="fr-FR"/>
           </a:p>
@@ -2817,7 +2825,7 @@
           <a:p>
             <a:fld id="{EBB3AEE8-3EC3-44A2-86E6-306757BFC25E}" type="datetimeFigureOut">
               <a:rPr lang="fr-FR" smtClean="0"/>
-              <a:t>17/06/2026</a:t>
+              <a:t>23/06/2026</a:t>
             </a:fld>
             <a:endParaRPr lang="fr-FR"/>
           </a:p>
@@ -3144,7 +3152,7 @@
           <a:p>
             <a:fld id="{EBB3AEE8-3EC3-44A2-86E6-306757BFC25E}" type="datetimeFigureOut">
               <a:rPr lang="fr-FR" smtClean="0"/>
-              <a:t>17/06/2026</a:t>
+              <a:t>23/06/2026</a:t>
             </a:fld>
             <a:endParaRPr lang="fr-FR"/>
           </a:p>
@@ -3779,7 +3787,7 @@
           <p:cNvPr id="2" name="Titre 1">
             <a:extLst>
               <a:ext uri="{FF2B5EF4-FFF2-40B4-BE49-F238E27FC236}">
-                <a16:creationId xmlns:a16="http://schemas.microsoft.com/office/drawing/2014/main" id="{ECE23881-A07C-4412-B0D7-175696A0B674}"/>
+                <a16:creationId xmlns:a16="http://schemas.microsoft.com/office/drawing/2014/main" id="{FD1FA03B-EC0F-4BEF-B66A-ABD00BB1AE7D}"/>
               </a:ext>
             </a:extLst>
           </p:cNvPr>
@@ -3790,59 +3798,492 @@
             <p:ph type="title"/>
           </p:nvPr>
         </p:nvSpPr>
-        <p:spPr/>
+        <p:spPr>
+          <a:xfrm>
+            <a:off x="1076929" y="163169"/>
+            <a:ext cx="9603275" cy="1430681"/>
+          </a:xfrm>
+        </p:spPr>
         <p:txBody>
           <a:bodyPr>
-            <a:normAutofit/>
+            <a:noAutofit/>
           </a:bodyPr>
           <a:lstStyle/>
           <a:p>
             <a:pPr algn="ctr"/>
             <a:r>
-              <a:rPr lang="en-US" sz="4400" dirty="0"/>
-              <a:t>DEMONSTRATION LIVE DU SITE</a:t>
-            </a:r>
-            <a:endParaRPr lang="fr-FR" sz="4400" dirty="0"/>
-          </a:p>
-        </p:txBody>
-      </p:sp>
-      <p:sp>
-        <p:nvSpPr>
-          <p:cNvPr id="3" name="Espace réservé du contenu 2">
+              <a:rPr lang="en-US" sz="4800" b="1" dirty="0"/>
+              <a:t> DIFFiCULTEs RENCONTRE ET SOLUTIONs</a:t>
+            </a:r>
+            <a:endParaRPr lang="fr-FR" sz="4800" b="1" dirty="0"/>
+          </a:p>
+        </p:txBody>
+      </p:sp>
+      <p:sp>
+        <p:nvSpPr>
+          <p:cNvPr id="4" name="Rectangle 1">
             <a:extLst>
               <a:ext uri="{FF2B5EF4-FFF2-40B4-BE49-F238E27FC236}">
-                <a16:creationId xmlns:a16="http://schemas.microsoft.com/office/drawing/2014/main" id="{86CA909E-7D92-47B0-ACC3-39B472521DD6}"/>
+                <a16:creationId xmlns:a16="http://schemas.microsoft.com/office/drawing/2014/main" id="{6D16FAED-D4ED-4283-BFF7-7E52EB09EC71}"/>
               </a:ext>
             </a:extLst>
           </p:cNvPr>
           <p:cNvSpPr>
-            <a:spLocks noGrp="1"/>
+            <a:spLocks noGrp="1" noChangeArrowheads="1"/>
           </p:cNvSpPr>
           <p:nvPr>
             <p:ph idx="1"/>
           </p:nvPr>
         </p:nvSpPr>
-        <p:spPr/>
-        <p:txBody>
-          <a:bodyPr>
-            <a:normAutofit/>
+        <p:spPr bwMode="auto">
+          <a:xfrm>
+            <a:off x="1150577" y="2020179"/>
+            <a:ext cx="4378122" cy="3416320"/>
+          </a:xfrm>
+          <a:prstGeom prst="rect">
+            <a:avLst/>
+          </a:prstGeom>
+          <a:noFill/>
+          <a:ln>
+            <a:noFill/>
+          </a:ln>
+          <a:effectLst/>
+          <a:extLst>
+            <a:ext uri="{909E8E84-426E-40DD-AFC4-6F175D3DCCD1}">
+              <a14:hiddenFill xmlns:a14="http://schemas.microsoft.com/office/drawing/2010/main">
+                <a:solidFill>
+                  <a:schemeClr val="accent1"/>
+                </a:solidFill>
+              </a14:hiddenFill>
+            </a:ext>
+            <a:ext uri="{91240B29-F687-4F45-9708-019B960494DF}">
+              <a14:hiddenLine xmlns:a14="http://schemas.microsoft.com/office/drawing/2010/main" w="9525">
+                <a:solidFill>
+                  <a:schemeClr val="tx1"/>
+                </a:solidFill>
+                <a:miter lim="800000"/>
+                <a:headEnd/>
+                <a:tailEnd/>
+              </a14:hiddenLine>
+            </a:ext>
+            <a:ext uri="{AF507438-7753-43E0-B8FC-AC1667EBCBE1}">
+              <a14:hiddenEffects xmlns:a14="http://schemas.microsoft.com/office/drawing/2010/main">
+                <a:effectLst>
+                  <a:outerShdw dist="35921" dir="2700000" algn="ctr" rotWithShape="0">
+                    <a:schemeClr val="bg2"/>
+                  </a:outerShdw>
+                </a:effectLst>
+              </a14:hiddenEffects>
+            </a:ext>
+          </a:extLst>
+        </p:spPr>
+        <p:txBody>
+          <a:bodyPr vert="horz" wrap="none" lIns="91440" tIns="45720" rIns="91440" bIns="45720" numCol="1" anchor="ctr" anchorCtr="0" compatLnSpc="1">
+            <a:prstTxWarp prst="textNoShape">
+              <a:avLst/>
+            </a:prstTxWarp>
+            <a:spAutoFit/>
           </a:bodyPr>
           <a:lstStyle/>
           <a:p>
-            <a:r>
-              <a:rPr lang="fr-FR" sz="2800" dirty="0">
-                <a:latin typeface="Times New Roman" panose="02020603050405020304" pitchFamily="18" charset="0"/>
-                <a:cs typeface="Times New Roman" panose="02020603050405020304" pitchFamily="18" charset="0"/>
-              </a:rPr>
-              <a:t>“AfriTalent est une plateforme web responsive développée avec HTML, CSS, JavaScript et Bootstrap. Le projet met en relation des freelances africains et des entreprises tout en intégrant plusieurs fonctionnalités dynamiques pour améliorer l’expérience utilisateur.”</a:t>
-            </a:r>
+            <a:pPr marL="0" marR="0" lvl="0" indent="0" algn="just" defTabSz="914400" rtl="0" eaLnBrk="0" fontAlgn="base" latinLnBrk="0" hangingPunct="0">
+              <a:lnSpc>
+                <a:spcPct val="100000"/>
+              </a:lnSpc>
+              <a:spcBef>
+                <a:spcPct val="0"/>
+              </a:spcBef>
+              <a:spcAft>
+                <a:spcPct val="0"/>
+              </a:spcAft>
+              <a:buClrTx/>
+              <a:buSzTx/>
+              <a:buFontTx/>
+              <a:buNone/>
+              <a:tabLst/>
+            </a:pPr>
+            <a:r>
+              <a:rPr kumimoji="0" lang="fr-FR" altLang="fr-FR" sz="1800" b="0" i="0" u="none" strike="noStrike" cap="none" normalizeH="0" baseline="0" dirty="0">
+                <a:ln>
+                  <a:noFill/>
+                </a:ln>
+                <a:solidFill>
+                  <a:schemeClr val="tx1"/>
+                </a:solidFill>
+                <a:effectLst/>
+                <a:latin typeface="Times New Roman" panose="02020603050405020304" pitchFamily="18" charset="0"/>
+                <a:cs typeface="Times New Roman" panose="02020603050405020304" pitchFamily="18" charset="0"/>
+              </a:rPr>
+              <a:t>-Les difficultes rencontre</a:t>
+            </a:r>
+          </a:p>
+          <a:p>
+            <a:pPr marL="0" marR="0" lvl="0" indent="0" algn="just" defTabSz="914400" rtl="0" eaLnBrk="0" fontAlgn="base" latinLnBrk="0" hangingPunct="0">
+              <a:lnSpc>
+                <a:spcPct val="100000"/>
+              </a:lnSpc>
+              <a:spcBef>
+                <a:spcPct val="0"/>
+              </a:spcBef>
+              <a:spcAft>
+                <a:spcPct val="0"/>
+              </a:spcAft>
+              <a:buClrTx/>
+              <a:buSzTx/>
+              <a:buFontTx/>
+              <a:buChar char="•"/>
+              <a:tabLst/>
+            </a:pPr>
+            <a:r>
+              <a:rPr kumimoji="0" lang="fr-FR" altLang="fr-FR" sz="1800" b="0" i="0" u="none" strike="noStrike" cap="none" normalizeH="0" baseline="0" dirty="0">
+                <a:ln>
+                  <a:noFill/>
+                </a:ln>
+                <a:solidFill>
+                  <a:schemeClr val="tx1"/>
+                </a:solidFill>
+                <a:effectLst/>
+                <a:latin typeface="Times New Roman" panose="02020603050405020304" pitchFamily="18" charset="0"/>
+                <a:cs typeface="Times New Roman" panose="02020603050405020304" pitchFamily="18" charset="0"/>
+              </a:rPr>
+              <a:t>balise &lt;section&gt; non fermée </a:t>
+            </a:r>
+          </a:p>
+          <a:p>
+            <a:pPr marL="0" marR="0" lvl="0" indent="0" algn="just" defTabSz="914400" rtl="0" eaLnBrk="0" fontAlgn="base" latinLnBrk="0" hangingPunct="0">
+              <a:lnSpc>
+                <a:spcPct val="100000"/>
+              </a:lnSpc>
+              <a:spcBef>
+                <a:spcPct val="0"/>
+              </a:spcBef>
+              <a:spcAft>
+                <a:spcPct val="0"/>
+              </a:spcAft>
+              <a:buClrTx/>
+              <a:buSzTx/>
+              <a:buFontTx/>
+              <a:buChar char="•"/>
+              <a:tabLst/>
+            </a:pPr>
+            <a:r>
+              <a:rPr lang="fr-FR" altLang="fr-FR" sz="1800" dirty="0">
+                <a:latin typeface="Times New Roman" panose="02020603050405020304" pitchFamily="18" charset="0"/>
+                <a:cs typeface="Times New Roman" panose="02020603050405020304" pitchFamily="18" charset="0"/>
+              </a:rPr>
+              <a:t>Erreur des images</a:t>
+            </a:r>
+            <a:endParaRPr kumimoji="0" lang="fr-FR" altLang="fr-FR" sz="1800" b="0" i="0" u="none" strike="noStrike" cap="none" normalizeH="0" baseline="0" dirty="0">
+              <a:ln>
+                <a:noFill/>
+              </a:ln>
+              <a:solidFill>
+                <a:schemeClr val="tx1"/>
+              </a:solidFill>
+              <a:effectLst/>
+              <a:latin typeface="Times New Roman" panose="02020603050405020304" pitchFamily="18" charset="0"/>
+              <a:cs typeface="Times New Roman" panose="02020603050405020304" pitchFamily="18" charset="0"/>
+            </a:endParaRPr>
+          </a:p>
+          <a:p>
+            <a:pPr marL="0" marR="0" lvl="0" indent="0" algn="just" defTabSz="914400" rtl="0" eaLnBrk="0" fontAlgn="base" latinLnBrk="0" hangingPunct="0">
+              <a:lnSpc>
+                <a:spcPct val="100000"/>
+              </a:lnSpc>
+              <a:spcBef>
+                <a:spcPct val="0"/>
+              </a:spcBef>
+              <a:spcAft>
+                <a:spcPct val="0"/>
+              </a:spcAft>
+              <a:buClrTx/>
+              <a:buSzTx/>
+              <a:buFontTx/>
+              <a:buChar char="•"/>
+              <a:tabLst/>
+            </a:pPr>
+            <a:r>
+              <a:rPr kumimoji="0" lang="fr-FR" altLang="fr-FR" sz="1800" b="0" i="0" u="none" strike="noStrike" cap="none" normalizeH="0" baseline="0" dirty="0">
+                <a:ln>
+                  <a:noFill/>
+                </a:ln>
+                <a:solidFill>
+                  <a:schemeClr val="tx1"/>
+                </a:solidFill>
+                <a:effectLst/>
+                <a:latin typeface="Times New Roman" panose="02020603050405020304" pitchFamily="18" charset="0"/>
+                <a:cs typeface="Times New Roman" panose="02020603050405020304" pitchFamily="18" charset="0"/>
+              </a:rPr>
+              <a:t>commentaire HTML mal fermé </a:t>
+            </a:r>
+          </a:p>
+          <a:p>
+            <a:pPr marL="0" marR="0" lvl="0" indent="0" algn="just" defTabSz="914400" rtl="0" eaLnBrk="0" fontAlgn="base" latinLnBrk="0" hangingPunct="0">
+              <a:lnSpc>
+                <a:spcPct val="100000"/>
+              </a:lnSpc>
+              <a:spcBef>
+                <a:spcPct val="0"/>
+              </a:spcBef>
+              <a:spcAft>
+                <a:spcPct val="0"/>
+              </a:spcAft>
+              <a:buClrTx/>
+              <a:buSzTx/>
+              <a:buFontTx/>
+              <a:buChar char="•"/>
+              <a:tabLst/>
+            </a:pPr>
+            <a:r>
+              <a:rPr kumimoji="0" lang="fr-FR" altLang="fr-FR" sz="1800" b="0" i="0" u="none" strike="noStrike" cap="none" normalizeH="0" baseline="0" dirty="0">
+                <a:ln>
+                  <a:noFill/>
+                </a:ln>
+                <a:solidFill>
+                  <a:schemeClr val="tx1"/>
+                </a:solidFill>
+                <a:effectLst/>
+                <a:latin typeface="Times New Roman" panose="02020603050405020304" pitchFamily="18" charset="0"/>
+                <a:cs typeface="Times New Roman" panose="02020603050405020304" pitchFamily="18" charset="0"/>
+              </a:rPr>
+              <a:t>erreur dans le lien </a:t>
+            </a:r>
+          </a:p>
+          <a:p>
+            <a:pPr marL="0" marR="0" lvl="0" indent="0" algn="just" defTabSz="914400" rtl="0" eaLnBrk="0" fontAlgn="base" latinLnBrk="0" hangingPunct="0">
+              <a:lnSpc>
+                <a:spcPct val="100000"/>
+              </a:lnSpc>
+              <a:spcBef>
+                <a:spcPct val="0"/>
+              </a:spcBef>
+              <a:spcAft>
+                <a:spcPct val="0"/>
+              </a:spcAft>
+              <a:buClrTx/>
+              <a:buSzTx/>
+              <a:buNone/>
+              <a:tabLst/>
+            </a:pPr>
+            <a:r>
+              <a:rPr kumimoji="0" lang="fr-FR" altLang="fr-FR" sz="1800" b="0" i="0" u="none" strike="noStrike" cap="none" normalizeH="0" baseline="0" dirty="0">
+                <a:ln>
+                  <a:noFill/>
+                </a:ln>
+                <a:solidFill>
+                  <a:schemeClr val="tx1"/>
+                </a:solidFill>
+                <a:effectLst/>
+                <a:latin typeface="Times New Roman" panose="02020603050405020304" pitchFamily="18" charset="0"/>
+                <a:cs typeface="Times New Roman" panose="02020603050405020304" pitchFamily="18" charset="0"/>
+              </a:rPr>
+              <a:t>-Les Solutions</a:t>
+            </a:r>
+          </a:p>
+          <a:p>
+            <a:pPr marL="0" marR="0" lvl="0" indent="0" algn="just" defTabSz="914400" rtl="0" eaLnBrk="0" fontAlgn="base" latinLnBrk="0" hangingPunct="0">
+              <a:lnSpc>
+                <a:spcPct val="100000"/>
+              </a:lnSpc>
+              <a:spcBef>
+                <a:spcPct val="0"/>
+              </a:spcBef>
+              <a:spcAft>
+                <a:spcPct val="0"/>
+              </a:spcAft>
+              <a:buClrTx/>
+              <a:buSzTx/>
+              <a:buNone/>
+              <a:tabLst/>
+            </a:pPr>
+            <a:r>
+              <a:rPr kumimoji="0" lang="fr-FR" altLang="fr-FR" sz="1800" b="0" i="0" u="none" strike="noStrike" cap="none" normalizeH="0" baseline="0" dirty="0">
+                <a:ln>
+                  <a:noFill/>
+                </a:ln>
+                <a:solidFill>
+                  <a:schemeClr val="tx1"/>
+                </a:solidFill>
+                <a:effectLst/>
+                <a:latin typeface="Times New Roman" panose="02020603050405020304" pitchFamily="18" charset="0"/>
+                <a:cs typeface="Times New Roman" panose="02020603050405020304" pitchFamily="18" charset="0"/>
+              </a:rPr>
+              <a:t>.Verification ligne par ligne du code</a:t>
+            </a:r>
+          </a:p>
+          <a:p>
+            <a:pPr marL="0" marR="0" lvl="0" indent="0" algn="just" defTabSz="914400" rtl="0" eaLnBrk="0" fontAlgn="base" latinLnBrk="0" hangingPunct="0">
+              <a:lnSpc>
+                <a:spcPct val="100000"/>
+              </a:lnSpc>
+              <a:spcBef>
+                <a:spcPct val="0"/>
+              </a:spcBef>
+              <a:spcAft>
+                <a:spcPct val="0"/>
+              </a:spcAft>
+              <a:buClrTx/>
+              <a:buSzTx/>
+              <a:buNone/>
+              <a:tabLst/>
+            </a:pPr>
+            <a:r>
+              <a:rPr lang="fr-FR" altLang="fr-FR" sz="1800" dirty="0">
+                <a:latin typeface="Times New Roman" panose="02020603050405020304" pitchFamily="18" charset="0"/>
+                <a:cs typeface="Times New Roman" panose="02020603050405020304" pitchFamily="18" charset="0"/>
+              </a:rPr>
+              <a:t>.Verification des images</a:t>
+            </a:r>
+          </a:p>
+          <a:p>
+            <a:pPr marL="0" marR="0" lvl="0" indent="0" algn="just" defTabSz="914400" rtl="0" eaLnBrk="0" fontAlgn="base" latinLnBrk="0" hangingPunct="0">
+              <a:lnSpc>
+                <a:spcPct val="100000"/>
+              </a:lnSpc>
+              <a:spcBef>
+                <a:spcPct val="0"/>
+              </a:spcBef>
+              <a:spcAft>
+                <a:spcPct val="0"/>
+              </a:spcAft>
+              <a:buClrTx/>
+              <a:buSzTx/>
+              <a:buNone/>
+              <a:tabLst/>
+            </a:pPr>
+            <a:r>
+              <a:rPr kumimoji="0" lang="fr-FR" altLang="fr-FR" sz="1800" b="0" i="0" u="none" strike="noStrike" cap="none" normalizeH="0" baseline="0" dirty="0">
+                <a:ln>
+                  <a:noFill/>
+                </a:ln>
+                <a:solidFill>
+                  <a:schemeClr val="tx1"/>
+                </a:solidFill>
+                <a:effectLst/>
+                <a:latin typeface="Times New Roman" panose="02020603050405020304" pitchFamily="18" charset="0"/>
+                <a:cs typeface="Times New Roman" panose="02020603050405020304" pitchFamily="18" charset="0"/>
+              </a:rPr>
+              <a:t>.</a:t>
+            </a:r>
+            <a:r>
+              <a:rPr lang="fr-FR" altLang="fr-FR" sz="1800" dirty="0">
+                <a:latin typeface="Times New Roman" panose="02020603050405020304" pitchFamily="18" charset="0"/>
+                <a:cs typeface="Times New Roman" panose="02020603050405020304" pitchFamily="18" charset="0"/>
+              </a:rPr>
+              <a:t>Correction des balises ouvertes /non fermées</a:t>
+            </a:r>
+          </a:p>
+          <a:p>
+            <a:pPr marL="0" marR="0" lvl="0" indent="0" algn="just" defTabSz="914400" rtl="0" eaLnBrk="0" fontAlgn="base" latinLnBrk="0" hangingPunct="0">
+              <a:lnSpc>
+                <a:spcPct val="100000"/>
+              </a:lnSpc>
+              <a:spcBef>
+                <a:spcPct val="0"/>
+              </a:spcBef>
+              <a:spcAft>
+                <a:spcPct val="0"/>
+              </a:spcAft>
+              <a:buClrTx/>
+              <a:buSzTx/>
+              <a:buNone/>
+              <a:tabLst/>
+            </a:pPr>
+            <a:r>
+              <a:rPr kumimoji="0" lang="fr-FR" altLang="fr-FR" sz="1800" b="0" i="0" u="none" strike="noStrike" cap="none" normalizeH="0" baseline="0" dirty="0">
+                <a:ln>
+                  <a:noFill/>
+                </a:ln>
+                <a:solidFill>
+                  <a:schemeClr val="tx1"/>
+                </a:solidFill>
+                <a:effectLst/>
+                <a:latin typeface="Times New Roman" panose="02020603050405020304" pitchFamily="18" charset="0"/>
+                <a:cs typeface="Times New Roman" panose="02020603050405020304" pitchFamily="18" charset="0"/>
+              </a:rPr>
+              <a:t>.Correction des </a:t>
+            </a:r>
+            <a:r>
+              <a:rPr lang="fr-FR" altLang="fr-FR" sz="1800" dirty="0">
+                <a:latin typeface="Times New Roman" panose="02020603050405020304" pitchFamily="18" charset="0"/>
+                <a:cs typeface="Times New Roman" panose="02020603050405020304" pitchFamily="18" charset="0"/>
+              </a:rPr>
+              <a:t>Liens HTML</a:t>
+            </a:r>
+            <a:endParaRPr kumimoji="0" lang="fr-FR" altLang="fr-FR" sz="1800" b="0" i="0" u="none" strike="noStrike" cap="none" normalizeH="0" baseline="0" dirty="0">
+              <a:ln>
+                <a:noFill/>
+              </a:ln>
+              <a:solidFill>
+                <a:schemeClr val="tx1"/>
+              </a:solidFill>
+              <a:effectLst/>
+              <a:latin typeface="Times New Roman" panose="02020603050405020304" pitchFamily="18" charset="0"/>
+              <a:cs typeface="Times New Roman" panose="02020603050405020304" pitchFamily="18" charset="0"/>
+            </a:endParaRPr>
+          </a:p>
+          <a:p>
+            <a:pPr marL="0" marR="0" lvl="0" indent="0" algn="just" defTabSz="914400" rtl="0" eaLnBrk="0" fontAlgn="base" latinLnBrk="0" hangingPunct="0">
+              <a:lnSpc>
+                <a:spcPct val="100000"/>
+              </a:lnSpc>
+              <a:spcBef>
+                <a:spcPct val="0"/>
+              </a:spcBef>
+              <a:spcAft>
+                <a:spcPct val="0"/>
+              </a:spcAft>
+              <a:buClrTx/>
+              <a:buSzTx/>
+              <a:buNone/>
+              <a:tabLst/>
+            </a:pPr>
+            <a:endParaRPr kumimoji="0" lang="fr-FR" altLang="fr-FR" sz="1800" b="0" i="0" u="none" strike="noStrike" cap="none" normalizeH="0" baseline="0" dirty="0">
+              <a:ln>
+                <a:noFill/>
+              </a:ln>
+              <a:solidFill>
+                <a:schemeClr val="tx1"/>
+              </a:solidFill>
+              <a:effectLst/>
+              <a:latin typeface="Times New Roman" panose="02020603050405020304" pitchFamily="18" charset="0"/>
+              <a:cs typeface="Times New Roman" panose="02020603050405020304" pitchFamily="18" charset="0"/>
+            </a:endParaRPr>
+          </a:p>
+          <a:p>
+            <a:pPr marL="0" marR="0" lvl="0" indent="0" algn="just" defTabSz="914400" rtl="0" eaLnBrk="0" fontAlgn="base" latinLnBrk="0" hangingPunct="0">
+              <a:lnSpc>
+                <a:spcPct val="100000"/>
+              </a:lnSpc>
+              <a:spcBef>
+                <a:spcPct val="0"/>
+              </a:spcBef>
+              <a:spcAft>
+                <a:spcPct val="0"/>
+              </a:spcAft>
+              <a:buClrTx/>
+              <a:buSzTx/>
+              <a:buNone/>
+              <a:tabLst/>
+            </a:pPr>
+            <a:endParaRPr kumimoji="0" lang="fr-FR" altLang="fr-FR" sz="1800" b="0" i="0" u="none" strike="noStrike" cap="none" normalizeH="0" baseline="0" dirty="0">
+              <a:ln>
+                <a:noFill/>
+              </a:ln>
+              <a:solidFill>
+                <a:schemeClr val="tx1"/>
+              </a:solidFill>
+              <a:effectLst/>
+              <a:latin typeface="Times New Roman" panose="02020603050405020304" pitchFamily="18" charset="0"/>
+              <a:cs typeface="Times New Roman" panose="02020603050405020304" pitchFamily="18" charset="0"/>
+            </a:endParaRPr>
           </a:p>
         </p:txBody>
       </p:sp>
     </p:spTree>
     <p:extLst>
       <p:ext uri="{BB962C8B-B14F-4D97-AF65-F5344CB8AC3E}">
-        <p14:creationId xmlns:p14="http://schemas.microsoft.com/office/powerpoint/2010/main" val="2926243055"/>
+        <p14:creationId xmlns:p14="http://schemas.microsoft.com/office/powerpoint/2010/main" val="2298258776"/>
       </p:ext>
     </p:extLst>
   </p:cSld>
@@ -3874,6 +4315,415 @@
           <p:cNvPr id="2" name="Titre 1">
             <a:extLst>
               <a:ext uri="{FF2B5EF4-FFF2-40B4-BE49-F238E27FC236}">
+                <a16:creationId xmlns:a16="http://schemas.microsoft.com/office/drawing/2014/main" id="{82FA8760-1091-4653-B14A-97C7A0171642}"/>
+              </a:ext>
+            </a:extLst>
+          </p:cNvPr>
+          <p:cNvSpPr>
+            <a:spLocks noGrp="1"/>
+          </p:cNvSpPr>
+          <p:nvPr>
+            <p:ph type="title"/>
+          </p:nvPr>
+        </p:nvSpPr>
+        <p:spPr/>
+        <p:txBody>
+          <a:bodyPr>
+            <a:normAutofit fontScale="90000"/>
+          </a:bodyPr>
+          <a:lstStyle/>
+          <a:p>
+            <a:pPr algn="ctr"/>
+            <a:r>
+              <a:rPr lang="en-US" sz="3600" dirty="0">
+                <a:latin typeface="Arial Black" panose="020B0A04020102020204" pitchFamily="34" charset="0"/>
+              </a:rPr>
+              <a:t>RESOURCES ET DOCUMENTATION</a:t>
+            </a:r>
+            <a:br>
+              <a:rPr lang="en-US" sz="3600" dirty="0">
+                <a:latin typeface="Arial Black" panose="020B0A04020102020204" pitchFamily="34" charset="0"/>
+              </a:rPr>
+            </a:br>
+            <a:r>
+              <a:rPr lang="en-US" sz="3600" dirty="0">
+                <a:latin typeface="Arial Black" panose="020B0A04020102020204" pitchFamily="34" charset="0"/>
+              </a:rPr>
+              <a:t> UTILISEES</a:t>
+            </a:r>
+            <a:endParaRPr lang="fr-FR" sz="3600" dirty="0">
+              <a:latin typeface="Arial Black" panose="020B0A04020102020204" pitchFamily="34" charset="0"/>
+            </a:endParaRPr>
+          </a:p>
+        </p:txBody>
+      </p:sp>
+      <p:sp>
+        <p:nvSpPr>
+          <p:cNvPr id="3" name="Espace réservé du contenu 2">
+            <a:extLst>
+              <a:ext uri="{FF2B5EF4-FFF2-40B4-BE49-F238E27FC236}">
+                <a16:creationId xmlns:a16="http://schemas.microsoft.com/office/drawing/2014/main" id="{4794F903-71C8-4BA9-957A-00EE6211EA4E}"/>
+              </a:ext>
+            </a:extLst>
+          </p:cNvPr>
+          <p:cNvSpPr>
+            <a:spLocks noGrp="1"/>
+          </p:cNvSpPr>
+          <p:nvPr>
+            <p:ph idx="1"/>
+          </p:nvPr>
+        </p:nvSpPr>
+        <p:spPr>
+          <a:xfrm>
+            <a:off x="1210279" y="2218932"/>
+            <a:ext cx="9603275" cy="3450613"/>
+          </a:xfrm>
+        </p:spPr>
+        <p:txBody>
+          <a:bodyPr>
+            <a:normAutofit/>
+          </a:bodyPr>
+          <a:lstStyle/>
+          <a:p>
+            <a:r>
+              <a:rPr lang="fr-FR" sz="2800" dirty="0">
+                <a:latin typeface="Times New Roman" panose="02020603050405020304" pitchFamily="18" charset="0"/>
+                <a:cs typeface="Times New Roman" panose="02020603050405020304" pitchFamily="18" charset="0"/>
+              </a:rPr>
+              <a:t>“Pour réaliser AfriTalent, j’ai utilisé MDN pour apprendre HTML, CSS et JavaScript, Bootstrap pour créer une interface responsive, Google Fonts pour la typographie, GitHub pour gérer les versions, GitHub Pages pour le déploiement et W3C Validator pour vérifier et corriger les erreurs du code.”</a:t>
+            </a:r>
+          </a:p>
+        </p:txBody>
+      </p:sp>
+    </p:spTree>
+    <p:extLst>
+      <p:ext uri="{BB962C8B-B14F-4D97-AF65-F5344CB8AC3E}">
+        <p14:creationId xmlns:p14="http://schemas.microsoft.com/office/powerpoint/2010/main" val="263038865"/>
+      </p:ext>
+    </p:extLst>
+  </p:cSld>
+  <p:clrMapOvr>
+    <a:masterClrMapping/>
+  </p:clrMapOvr>
+</p:sld>
+</file>
+
+<file path=ppt/slides/slide12.xml><?xml version="1.0" encoding="utf-8"?>
+<p:sld xmlns:a="http://schemas.openxmlformats.org/drawingml/2006/main" xmlns:r="http://schemas.openxmlformats.org/officeDocument/2006/relationships" xmlns:p="http://schemas.openxmlformats.org/presentationml/2006/main">
+  <p:cSld>
+    <p:spTree>
+      <p:nvGrpSpPr>
+        <p:cNvPr id="1" name=""/>
+        <p:cNvGrpSpPr/>
+        <p:nvPr/>
+      </p:nvGrpSpPr>
+      <p:grpSpPr>
+        <a:xfrm>
+          <a:off x="0" y="0"/>
+          <a:ext cx="0" cy="0"/>
+          <a:chOff x="0" y="0"/>
+          <a:chExt cx="0" cy="0"/>
+        </a:xfrm>
+      </p:grpSpPr>
+      <p:sp>
+        <p:nvSpPr>
+          <p:cNvPr id="2" name="Titre 1">
+            <a:extLst>
+              <a:ext uri="{FF2B5EF4-FFF2-40B4-BE49-F238E27FC236}">
+                <a16:creationId xmlns:a16="http://schemas.microsoft.com/office/drawing/2014/main" id="{ECE23881-A07C-4412-B0D7-175696A0B674}"/>
+              </a:ext>
+            </a:extLst>
+          </p:cNvPr>
+          <p:cNvSpPr>
+            <a:spLocks noGrp="1"/>
+          </p:cNvSpPr>
+          <p:nvPr>
+            <p:ph type="title"/>
+          </p:nvPr>
+        </p:nvSpPr>
+        <p:spPr/>
+        <p:txBody>
+          <a:bodyPr>
+            <a:normAutofit/>
+          </a:bodyPr>
+          <a:lstStyle/>
+          <a:p>
+            <a:pPr algn="ctr"/>
+            <a:r>
+              <a:rPr lang="en-US" sz="4400" dirty="0"/>
+              <a:t>DEMONSTRATION LIVE DU SITE</a:t>
+            </a:r>
+            <a:endParaRPr lang="fr-FR" sz="4400" dirty="0"/>
+          </a:p>
+        </p:txBody>
+      </p:sp>
+      <p:sp>
+        <p:nvSpPr>
+          <p:cNvPr id="3" name="Espace réservé du contenu 2">
+            <a:extLst>
+              <a:ext uri="{FF2B5EF4-FFF2-40B4-BE49-F238E27FC236}">
+                <a16:creationId xmlns:a16="http://schemas.microsoft.com/office/drawing/2014/main" id="{86CA909E-7D92-47B0-ACC3-39B472521DD6}"/>
+              </a:ext>
+            </a:extLst>
+          </p:cNvPr>
+          <p:cNvSpPr>
+            <a:spLocks noGrp="1"/>
+          </p:cNvSpPr>
+          <p:nvPr>
+            <p:ph idx="1"/>
+          </p:nvPr>
+        </p:nvSpPr>
+        <p:spPr>
+          <a:xfrm>
+            <a:off x="1451579" y="1853754"/>
+            <a:ext cx="9603275" cy="4199727"/>
+          </a:xfrm>
+        </p:spPr>
+        <p:txBody>
+          <a:bodyPr>
+            <a:normAutofit fontScale="25000" lnSpcReduction="20000"/>
+          </a:bodyPr>
+          <a:lstStyle/>
+          <a:p>
+            <a:r>
+              <a:rPr lang="fr-FR" sz="7200" b="1" dirty="0"/>
+              <a:t>Présentation des fonctionnalités principales</a:t>
+            </a:r>
+          </a:p>
+          <a:p>
+            <a:r>
+              <a:rPr lang="fr-FR" sz="7200" dirty="0"/>
+              <a:t>Pendant la démonstration, les </a:t>
+            </a:r>
+            <a:r>
+              <a:rPr lang="fr-FR" sz="7200" dirty="0">
+                <a:latin typeface="Times New Roman" panose="02020603050405020304" pitchFamily="18" charset="0"/>
+                <a:cs typeface="Times New Roman" panose="02020603050405020304" pitchFamily="18" charset="0"/>
+              </a:rPr>
+              <a:t>fonctionnalités</a:t>
+            </a:r>
+            <a:r>
+              <a:rPr lang="fr-FR" sz="7200" dirty="0"/>
+              <a:t> suivantes seront présentées :</a:t>
+            </a:r>
+          </a:p>
+          <a:p>
+            <a:r>
+              <a:rPr lang="fr-FR" sz="7200" b="1" dirty="0"/>
+              <a:t>Page d’accueil</a:t>
+            </a:r>
+            <a:r>
+              <a:rPr lang="fr-FR" sz="7200" dirty="0"/>
+              <a:t> : présentation de la plateforme AfriTalent et navigation principale.</a:t>
+            </a:r>
+          </a:p>
+          <a:p>
+            <a:r>
+              <a:rPr lang="fr-FR" sz="7200" dirty="0"/>
+              <a:t> </a:t>
+            </a:r>
+            <a:r>
+              <a:rPr lang="fr-FR" sz="7200" b="1" dirty="0"/>
+              <a:t>Navigation responsive</a:t>
+            </a:r>
+            <a:r>
+              <a:rPr lang="fr-FR" sz="7200" dirty="0"/>
+              <a:t> : menu qui s’adapte aux ordinateurs, tablettes et téléphones grâce à Bootstrap.</a:t>
+            </a:r>
+          </a:p>
+          <a:p>
+            <a:r>
+              <a:rPr lang="fr-FR" sz="7200" dirty="0"/>
+              <a:t> </a:t>
+            </a:r>
+            <a:r>
+              <a:rPr lang="fr-FR" sz="7200" b="1" dirty="0"/>
+              <a:t>Section services</a:t>
+            </a:r>
+            <a:r>
+              <a:rPr lang="fr-FR" sz="7200" dirty="0"/>
+              <a:t> : affichage des différentes catégories de services proposées aux freelances.</a:t>
+            </a:r>
+          </a:p>
+          <a:p>
+            <a:r>
+              <a:rPr lang="fr-FR" sz="7200" dirty="0"/>
+              <a:t> </a:t>
+            </a:r>
+            <a:r>
+              <a:rPr lang="fr-FR" sz="7200" b="1" dirty="0"/>
+              <a:t>Section témoignages</a:t>
+            </a:r>
+            <a:r>
+              <a:rPr lang="fr-FR" sz="7200" dirty="0"/>
+              <a:t> : carousel interactif permettant de faire défiler les avis clients.</a:t>
+            </a:r>
+          </a:p>
+          <a:p>
+            <a:r>
+              <a:rPr lang="fr-FR" sz="7200" b="1" dirty="0"/>
+              <a:t>Mode sombre / clair</a:t>
+            </a:r>
+            <a:r>
+              <a:rPr lang="fr-FR" sz="7200" dirty="0"/>
+              <a:t> : changement dynamique du thème grâce à JavaScript.</a:t>
+            </a:r>
+          </a:p>
+          <a:p>
+            <a:r>
+              <a:rPr lang="fr-FR" sz="7200" b="1" dirty="0"/>
+              <a:t>Bouton retour en haut</a:t>
+            </a:r>
+            <a:r>
+              <a:rPr lang="fr-FR" sz="7200" dirty="0"/>
+              <a:t> : amélioration de l’expérience utilisateur pendant la navigation.</a:t>
+            </a:r>
+          </a:p>
+          <a:p>
+            <a:r>
+              <a:rPr lang="fr-FR" sz="7200" dirty="0"/>
+              <a:t> </a:t>
+            </a:r>
+            <a:r>
+              <a:rPr lang="fr-FR" sz="7200" b="1" dirty="0"/>
+              <a:t>Pages supplémentaires</a:t>
+            </a:r>
+            <a:r>
+              <a:rPr lang="fr-FR" sz="7200" dirty="0"/>
+              <a:t> : accès aux pages Freelances, Tarifs, Contact et À propos</a:t>
+            </a:r>
+          </a:p>
+          <a:p>
+            <a:r>
+              <a:rPr lang="fr-FR" sz="6600" b="1" i="0" dirty="0">
+                <a:solidFill>
+                  <a:srgbClr val="1F2328"/>
+                </a:solidFill>
+                <a:effectLst/>
+                <a:latin typeface="Mona Sans VF"/>
+              </a:rPr>
+              <a:t> </a:t>
+            </a:r>
+            <a:r>
+              <a:rPr lang="fr-FR" sz="6600" b="1" i="0" u="sng" dirty="0">
+                <a:solidFill>
+                  <a:srgbClr val="0969DA"/>
+                </a:solidFill>
+                <a:effectLst/>
+                <a:latin typeface="Mona Sans VF"/>
+                <a:hlinkClick r:id="rId2"/>
+              </a:rPr>
+              <a:t>https://diao91627-coder.github.io/Aissatou_DIAO_AfriTalent/</a:t>
+            </a:r>
+            <a:endParaRPr lang="fr-FR" sz="7200" dirty="0">
+              <a:latin typeface="Times New Roman" panose="02020603050405020304" pitchFamily="18" charset="0"/>
+              <a:cs typeface="Times New Roman" panose="02020603050405020304" pitchFamily="18" charset="0"/>
+            </a:endParaRPr>
+          </a:p>
+          <a:p>
+            <a:endParaRPr lang="fr-FR" sz="6400" b="1" i="0" dirty="0">
+              <a:solidFill>
+                <a:srgbClr val="1F2328"/>
+              </a:solidFill>
+              <a:effectLst/>
+              <a:latin typeface="Mona Sans VF"/>
+            </a:endParaRPr>
+          </a:p>
+          <a:p>
+            <a:endParaRPr lang="fr-FR" sz="2400" b="1" dirty="0">
+              <a:solidFill>
+                <a:srgbClr val="1F2328"/>
+              </a:solidFill>
+              <a:latin typeface="Mona Sans VF"/>
+            </a:endParaRPr>
+          </a:p>
+          <a:p>
+            <a:endParaRPr lang="fr-FR" sz="2400" b="1" i="0" dirty="0">
+              <a:solidFill>
+                <a:srgbClr val="1F2328"/>
+              </a:solidFill>
+              <a:effectLst/>
+              <a:latin typeface="Mona Sans VF"/>
+            </a:endParaRPr>
+          </a:p>
+          <a:p>
+            <a:endParaRPr lang="fr-FR" sz="2400" b="1" dirty="0">
+              <a:solidFill>
+                <a:srgbClr val="1F2328"/>
+              </a:solidFill>
+              <a:latin typeface="Mona Sans VF"/>
+            </a:endParaRPr>
+          </a:p>
+          <a:p>
+            <a:endParaRPr lang="fr-FR" sz="2400" b="1" i="0" dirty="0">
+              <a:solidFill>
+                <a:srgbClr val="1F2328"/>
+              </a:solidFill>
+              <a:effectLst/>
+              <a:latin typeface="Mona Sans VF"/>
+            </a:endParaRPr>
+          </a:p>
+          <a:p>
+            <a:endParaRPr lang="fr-FR" sz="2400" b="1" dirty="0">
+              <a:solidFill>
+                <a:srgbClr val="1F2328"/>
+              </a:solidFill>
+              <a:latin typeface="Mona Sans VF"/>
+            </a:endParaRPr>
+          </a:p>
+          <a:p>
+            <a:r>
+              <a:rPr lang="fr-FR" sz="2400" b="1" i="0" dirty="0">
+                <a:solidFill>
+                  <a:srgbClr val="1F2328"/>
+                </a:solidFill>
+                <a:effectLst/>
+                <a:latin typeface="Mona Sans VF"/>
+              </a:rPr>
+              <a:t>\</a:t>
+            </a:r>
+            <a:endParaRPr lang="fr-FR" sz="2800" dirty="0">
+              <a:latin typeface="Times New Roman" panose="02020603050405020304" pitchFamily="18" charset="0"/>
+              <a:cs typeface="Times New Roman" panose="02020603050405020304" pitchFamily="18" charset="0"/>
+            </a:endParaRPr>
+          </a:p>
+        </p:txBody>
+      </p:sp>
+    </p:spTree>
+    <p:extLst>
+      <p:ext uri="{BB962C8B-B14F-4D97-AF65-F5344CB8AC3E}">
+        <p14:creationId xmlns:p14="http://schemas.microsoft.com/office/powerpoint/2010/main" val="2926243055"/>
+      </p:ext>
+    </p:extLst>
+  </p:cSld>
+  <p:clrMapOvr>
+    <a:masterClrMapping/>
+  </p:clrMapOvr>
+</p:sld>
+</file>
+
+<file path=ppt/slides/slide13.xml><?xml version="1.0" encoding="utf-8"?>
+<p:sld xmlns:a="http://schemas.openxmlformats.org/drawingml/2006/main" xmlns:r="http://schemas.openxmlformats.org/officeDocument/2006/relationships" xmlns:p="http://schemas.openxmlformats.org/presentationml/2006/main">
+  <p:cSld>
+    <p:spTree>
+      <p:nvGrpSpPr>
+        <p:cNvPr id="1" name=""/>
+        <p:cNvGrpSpPr/>
+        <p:nvPr/>
+      </p:nvGrpSpPr>
+      <p:grpSpPr>
+        <a:xfrm>
+          <a:off x="0" y="0"/>
+          <a:ext cx="0" cy="0"/>
+          <a:chOff x="0" y="0"/>
+          <a:chExt cx="0" cy="0"/>
+        </a:xfrm>
+      </p:grpSpPr>
+      <p:sp>
+        <p:nvSpPr>
+          <p:cNvPr id="2" name="Titre 1">
+            <a:extLst>
+              <a:ext uri="{FF2B5EF4-FFF2-40B4-BE49-F238E27FC236}">
                 <a16:creationId xmlns:a16="http://schemas.microsoft.com/office/drawing/2014/main" id="{F84EE8E0-BBAA-498E-A8D2-9B7294B0076B}"/>
               </a:ext>
             </a:extLst>
@@ -3943,6 +4793,201 @@
     <p:extLst>
       <p:ext uri="{BB962C8B-B14F-4D97-AF65-F5344CB8AC3E}">
         <p14:creationId xmlns:p14="http://schemas.microsoft.com/office/powerpoint/2010/main" val="2139626193"/>
+      </p:ext>
+    </p:extLst>
+  </p:cSld>
+  <p:clrMapOvr>
+    <a:masterClrMapping/>
+  </p:clrMapOvr>
+</p:sld>
+</file>
+
+<file path=ppt/slides/slide14.xml><?xml version="1.0" encoding="utf-8"?>
+<p:sld xmlns:a="http://schemas.openxmlformats.org/drawingml/2006/main" xmlns:r="http://schemas.openxmlformats.org/officeDocument/2006/relationships" xmlns:p="http://schemas.openxmlformats.org/presentationml/2006/main">
+  <p:cSld>
+    <p:spTree>
+      <p:nvGrpSpPr>
+        <p:cNvPr id="1" name=""/>
+        <p:cNvGrpSpPr/>
+        <p:nvPr/>
+      </p:nvGrpSpPr>
+      <p:grpSpPr>
+        <a:xfrm>
+          <a:off x="0" y="0"/>
+          <a:ext cx="0" cy="0"/>
+          <a:chOff x="0" y="0"/>
+          <a:chExt cx="0" cy="0"/>
+        </a:xfrm>
+      </p:grpSpPr>
+      <p:sp>
+        <p:nvSpPr>
+          <p:cNvPr id="2" name="Titre 1">
+            <a:extLst>
+              <a:ext uri="{FF2B5EF4-FFF2-40B4-BE49-F238E27FC236}">
+                <a16:creationId xmlns:a16="http://schemas.microsoft.com/office/drawing/2014/main" id="{AB7DF3B3-124C-42D8-A14A-D2A2A669A7A9}"/>
+              </a:ext>
+            </a:extLst>
+          </p:cNvPr>
+          <p:cNvSpPr>
+            <a:spLocks noGrp="1"/>
+          </p:cNvSpPr>
+          <p:nvPr>
+            <p:ph type="title"/>
+          </p:nvPr>
+        </p:nvSpPr>
+        <p:spPr/>
+        <p:txBody>
+          <a:bodyPr>
+            <a:noAutofit/>
+          </a:bodyPr>
+          <a:lstStyle/>
+          <a:p>
+            <a:pPr algn="ctr"/>
+            <a:r>
+              <a:rPr lang="en-US" sz="4800" dirty="0"/>
+              <a:t>PERSPECTIVE d’amelioration</a:t>
+            </a:r>
+            <a:endParaRPr lang="fr-FR" sz="4800" dirty="0"/>
+          </a:p>
+        </p:txBody>
+      </p:sp>
+      <p:sp>
+        <p:nvSpPr>
+          <p:cNvPr id="3" name="Espace réservé du contenu 2">
+            <a:extLst>
+              <a:ext uri="{FF2B5EF4-FFF2-40B4-BE49-F238E27FC236}">
+                <a16:creationId xmlns:a16="http://schemas.microsoft.com/office/drawing/2014/main" id="{455D945D-F864-42C3-B8A4-3192417F5A43}"/>
+              </a:ext>
+            </a:extLst>
+          </p:cNvPr>
+          <p:cNvSpPr>
+            <a:spLocks noGrp="1"/>
+          </p:cNvSpPr>
+          <p:nvPr>
+            <p:ph idx="1"/>
+          </p:nvPr>
+        </p:nvSpPr>
+        <p:spPr/>
+        <p:txBody>
+          <a:bodyPr>
+            <a:normAutofit fontScale="77500" lnSpcReduction="20000"/>
+          </a:bodyPr>
+          <a:lstStyle/>
+          <a:p>
+            <a:r>
+              <a:rPr lang="fr-FR" b="1" dirty="0"/>
+              <a:t>Dans les prochaines versions du projet, plusieurs améliorations peuvent être ajoutées </a:t>
+            </a:r>
+            <a:r>
+              <a:rPr lang="fr-FR" dirty="0"/>
+              <a:t>:</a:t>
+            </a:r>
+          </a:p>
+          <a:p>
+            <a:r>
+              <a:rPr lang="fr-FR" b="1" dirty="0"/>
+              <a:t>Système de connexion et inscription</a:t>
+            </a:r>
+            <a:r>
+              <a:rPr lang="fr-FR" dirty="0"/>
+              <a:t> permettant aux freelances et entreprises de créer un compte personnel.</a:t>
+            </a:r>
+          </a:p>
+          <a:p>
+            <a:r>
+              <a:rPr lang="fr-FR" dirty="0"/>
+              <a:t> </a:t>
+            </a:r>
+            <a:r>
+              <a:rPr lang="fr-FR" b="1" dirty="0"/>
+              <a:t>Base de données</a:t>
+            </a:r>
+            <a:r>
+              <a:rPr lang="fr-FR" dirty="0"/>
+              <a:t> pour enregistrer les utilisateurs, les missions et les informations du site de façon dynamique.</a:t>
+            </a:r>
+          </a:p>
+          <a:p>
+            <a:r>
+              <a:rPr lang="fr-FR" dirty="0"/>
+              <a:t> </a:t>
+            </a:r>
+            <a:r>
+              <a:rPr lang="fr-FR" b="1" dirty="0"/>
+              <a:t>Messagerie interne</a:t>
+            </a:r>
+            <a:r>
+              <a:rPr lang="fr-FR" dirty="0"/>
+              <a:t> pour permettre la communication directe entre clients et freelances.</a:t>
+            </a:r>
+          </a:p>
+          <a:p>
+            <a:r>
+              <a:rPr lang="fr-FR" dirty="0"/>
+              <a:t> </a:t>
+            </a:r>
+            <a:r>
+              <a:rPr lang="fr-FR" b="1" dirty="0"/>
+              <a:t>Système de paiement sécurisé</a:t>
+            </a:r>
+            <a:r>
+              <a:rPr lang="fr-FR" dirty="0"/>
+              <a:t> pour faciliter les transactions en ligne entre les utilisateurs.</a:t>
+            </a:r>
+          </a:p>
+          <a:p>
+            <a:r>
+              <a:rPr lang="fr-FR" dirty="0"/>
+              <a:t> </a:t>
+            </a:r>
+            <a:r>
+              <a:rPr lang="fr-FR" b="1" dirty="0"/>
+              <a:t>Amélioration du responsive design</a:t>
+            </a:r>
+            <a:r>
+              <a:rPr lang="fr-FR" dirty="0"/>
+              <a:t> pour une meilleure expérience sur tous les appareils mobiles.</a:t>
+            </a:r>
+          </a:p>
+          <a:p>
+            <a:r>
+              <a:rPr lang="fr-FR" dirty="0"/>
+              <a:t> </a:t>
+            </a:r>
+            <a:r>
+              <a:rPr lang="fr-FR" b="1" dirty="0"/>
+              <a:t>Ajout d’un moteur de recherche avancé</a:t>
+            </a:r>
+            <a:r>
+              <a:rPr lang="fr-FR" dirty="0"/>
+              <a:t> pour trouver rapidement un freelance selon ses compétences.</a:t>
+            </a:r>
+          </a:p>
+          <a:p>
+            <a:r>
+              <a:rPr lang="fr-FR" dirty="0"/>
+              <a:t> </a:t>
+            </a:r>
+            <a:r>
+              <a:rPr lang="fr-FR" b="1" dirty="0"/>
+              <a:t>Déploiement complet en ligne</a:t>
+            </a:r>
+            <a:r>
+              <a:rPr lang="fr-FR" dirty="0"/>
+              <a:t> avec un hébergement professionnel et un nom de domaine personnalisé.</a:t>
+            </a:r>
+          </a:p>
+          <a:p>
+            <a:endParaRPr lang="fr-FR" dirty="0">
+              <a:latin typeface="Arial Black" panose="020B0A04020102020204" pitchFamily="34" charset="0"/>
+            </a:endParaRPr>
+          </a:p>
+        </p:txBody>
+      </p:sp>
+    </p:spTree>
+    <p:extLst>
+      <p:ext uri="{BB962C8B-B14F-4D97-AF65-F5344CB8AC3E}">
+        <p14:creationId xmlns:p14="http://schemas.microsoft.com/office/powerpoint/2010/main" val="1223257436"/>
       </p:ext>
     </p:extLst>
   </p:cSld>
@@ -4571,7 +5616,7 @@
         </p:nvSpPr>
         <p:spPr>
           <a:xfrm>
-            <a:off x="1451579" y="2015732"/>
+            <a:off x="1419014" y="2086221"/>
             <a:ext cx="9603275" cy="4037749"/>
           </a:xfrm>
         </p:spPr>
@@ -4904,6 +5949,182 @@
           </a:p>
         </p:txBody>
       </p:sp>
+      <p:pic>
+        <p:nvPicPr>
+          <p:cNvPr id="7" name="Image 6">
+            <a:extLst>
+              <a:ext uri="{FF2B5EF4-FFF2-40B4-BE49-F238E27FC236}">
+                <a16:creationId xmlns:a16="http://schemas.microsoft.com/office/drawing/2014/main" id="{53EB6A14-7D31-4FBE-BD9F-19F36B09B02E}"/>
+              </a:ext>
+            </a:extLst>
+          </p:cNvPr>
+          <p:cNvPicPr>
+            <a:picLocks noChangeAspect="1"/>
+          </p:cNvPicPr>
+          <p:nvPr/>
+        </p:nvPicPr>
+        <p:blipFill>
+          <a:blip r:embed="rId2">
+            <a:extLst>
+              <a:ext uri="{28A0092B-C50C-407E-A947-70E740481C1C}">
+                <a14:useLocalDpi xmlns:a14="http://schemas.microsoft.com/office/drawing/2010/main" val="0"/>
+              </a:ext>
+            </a:extLst>
+          </a:blip>
+          <a:stretch>
+            <a:fillRect/>
+          </a:stretch>
+        </p:blipFill>
+        <p:spPr>
+          <a:xfrm>
+            <a:off x="6671732" y="2167020"/>
+            <a:ext cx="2345276" cy="1388979"/>
+          </a:xfrm>
+          <a:prstGeom prst="rect">
+            <a:avLst/>
+          </a:prstGeom>
+        </p:spPr>
+      </p:pic>
+      <p:sp>
+        <p:nvSpPr>
+          <p:cNvPr id="8" name="ZoneTexte 7">
+            <a:extLst>
+              <a:ext uri="{FF2B5EF4-FFF2-40B4-BE49-F238E27FC236}">
+                <a16:creationId xmlns:a16="http://schemas.microsoft.com/office/drawing/2014/main" id="{6A4176F6-819D-46CC-80DC-43547DC2AEB2}"/>
+              </a:ext>
+            </a:extLst>
+          </p:cNvPr>
+          <p:cNvSpPr txBox="1"/>
+          <p:nvPr/>
+        </p:nvSpPr>
+        <p:spPr>
+          <a:xfrm>
+            <a:off x="10727267" y="3090333"/>
+            <a:ext cx="45719" cy="369332"/>
+          </a:xfrm>
+          <a:prstGeom prst="rect">
+            <a:avLst/>
+          </a:prstGeom>
+          <a:noFill/>
+        </p:spPr>
+        <p:txBody>
+          <a:bodyPr wrap="square" rtlCol="0">
+            <a:spAutoFit/>
+          </a:bodyPr>
+          <a:lstStyle/>
+          <a:p>
+            <a:endParaRPr lang="fr-FR" dirty="0"/>
+          </a:p>
+        </p:txBody>
+      </p:sp>
+      <p:pic>
+        <p:nvPicPr>
+          <p:cNvPr id="10" name="Image 9">
+            <a:extLst>
+              <a:ext uri="{FF2B5EF4-FFF2-40B4-BE49-F238E27FC236}">
+                <a16:creationId xmlns:a16="http://schemas.microsoft.com/office/drawing/2014/main" id="{5FF3D5DE-7CD9-4FB2-A61F-7B29AF38B9DE}"/>
+              </a:ext>
+            </a:extLst>
+          </p:cNvPr>
+          <p:cNvPicPr>
+            <a:picLocks noChangeAspect="1"/>
+          </p:cNvPicPr>
+          <p:nvPr/>
+        </p:nvPicPr>
+        <p:blipFill>
+          <a:blip r:embed="rId3">
+            <a:extLst>
+              <a:ext uri="{28A0092B-C50C-407E-A947-70E740481C1C}">
+                <a14:useLocalDpi xmlns:a14="http://schemas.microsoft.com/office/drawing/2010/main" val="0"/>
+              </a:ext>
+            </a:extLst>
+          </a:blip>
+          <a:stretch>
+            <a:fillRect/>
+          </a:stretch>
+        </p:blipFill>
+        <p:spPr>
+          <a:xfrm>
+            <a:off x="9492826" y="2167020"/>
+            <a:ext cx="2514600" cy="1388979"/>
+          </a:xfrm>
+          <a:prstGeom prst="rect">
+            <a:avLst/>
+          </a:prstGeom>
+        </p:spPr>
+      </p:pic>
+      <p:pic>
+        <p:nvPicPr>
+          <p:cNvPr id="12" name="Image 11">
+            <a:extLst>
+              <a:ext uri="{FF2B5EF4-FFF2-40B4-BE49-F238E27FC236}">
+                <a16:creationId xmlns:a16="http://schemas.microsoft.com/office/drawing/2014/main" id="{C17BD30D-1ADF-4A34-B350-CE494F017A3D}"/>
+              </a:ext>
+            </a:extLst>
+          </p:cNvPr>
+          <p:cNvPicPr>
+            <a:picLocks noChangeAspect="1"/>
+          </p:cNvPicPr>
+          <p:nvPr/>
+        </p:nvPicPr>
+        <p:blipFill>
+          <a:blip r:embed="rId4">
+            <a:extLst>
+              <a:ext uri="{28A0092B-C50C-407E-A947-70E740481C1C}">
+                <a14:useLocalDpi xmlns:a14="http://schemas.microsoft.com/office/drawing/2010/main" val="0"/>
+              </a:ext>
+            </a:extLst>
+          </a:blip>
+          <a:stretch>
+            <a:fillRect/>
+          </a:stretch>
+        </p:blipFill>
+        <p:spPr>
+          <a:xfrm>
+            <a:off x="9642228" y="4105096"/>
+            <a:ext cx="2514600" cy="1558312"/>
+          </a:xfrm>
+          <a:prstGeom prst="rect">
+            <a:avLst/>
+          </a:prstGeom>
+        </p:spPr>
+      </p:pic>
+      <p:pic>
+        <p:nvPicPr>
+          <p:cNvPr id="14" name="Image 13">
+            <a:extLst>
+              <a:ext uri="{FF2B5EF4-FFF2-40B4-BE49-F238E27FC236}">
+                <a16:creationId xmlns:a16="http://schemas.microsoft.com/office/drawing/2014/main" id="{C5CAFEEA-B8D7-452F-8493-77361B738FC2}"/>
+              </a:ext>
+            </a:extLst>
+          </p:cNvPr>
+          <p:cNvPicPr>
+            <a:picLocks noChangeAspect="1"/>
+          </p:cNvPicPr>
+          <p:nvPr/>
+        </p:nvPicPr>
+        <p:blipFill>
+          <a:blip r:embed="rId5">
+            <a:extLst>
+              <a:ext uri="{28A0092B-C50C-407E-A947-70E740481C1C}">
+                <a14:useLocalDpi xmlns:a14="http://schemas.microsoft.com/office/drawing/2010/main" val="0"/>
+              </a:ext>
+            </a:extLst>
+          </a:blip>
+          <a:stretch>
+            <a:fillRect/>
+          </a:stretch>
+        </p:blipFill>
+        <p:spPr>
+          <a:xfrm>
+            <a:off x="6743704" y="4034606"/>
+            <a:ext cx="2201333" cy="1628802"/>
+          </a:xfrm>
+          <a:prstGeom prst="rect">
+            <a:avLst/>
+          </a:prstGeom>
+        </p:spPr>
+      </p:pic>
     </p:spTree>
     <p:extLst>
       <p:ext uri="{BB962C8B-B14F-4D97-AF65-F5344CB8AC3E}">
@@ -5477,10 +6698,15 @@
             <p:ph type="title"/>
           </p:nvPr>
         </p:nvSpPr>
-        <p:spPr/>
+        <p:spPr>
+          <a:xfrm>
+            <a:off x="1451579" y="296333"/>
+            <a:ext cx="9603275" cy="1557421"/>
+          </a:xfrm>
+        </p:spPr>
         <p:txBody>
           <a:bodyPr>
-            <a:normAutofit/>
+            <a:normAutofit fontScale="90000"/>
           </a:bodyPr>
           <a:lstStyle/>
           <a:p>
@@ -5492,6 +6718,26 @@
               </a:rPr>
               <a:t>POINT TECHNIQUE</a:t>
             </a:r>
+            <a:br>
+              <a:rPr lang="en-US" sz="6600" dirty="0">
+                <a:latin typeface="Times New Roman" panose="02020603050405020304" pitchFamily="18" charset="0"/>
+                <a:cs typeface="Times New Roman" panose="02020603050405020304" pitchFamily="18" charset="0"/>
+              </a:rPr>
+            </a:br>
+            <a:r>
+              <a:rPr lang="fr-FR" sz="1800" b="1" i="0" dirty="0">
+                <a:effectLst/>
+                <a:latin typeface="SegoeUI"/>
+              </a:rPr>
+              <a:t>JS (extraits de code + logique)</a:t>
+            </a:r>
+            <a:r>
+              <a:rPr lang="fr-FR" sz="4400" b="1" dirty="0"/>
+              <a:t> </a:t>
+            </a:r>
+            <a:br>
+              <a:rPr lang="fr-FR" sz="4400" dirty="0"/>
+            </a:br>
             <a:endParaRPr lang="fr-FR" sz="6600" dirty="0">
               <a:latin typeface="Times New Roman" panose="02020603050405020304" pitchFamily="18" charset="0"/>
               <a:cs typeface="Times New Roman" panose="02020603050405020304" pitchFamily="18" charset="0"/>
@@ -5517,8 +6763,8 @@
         </p:nvSpPr>
         <p:spPr>
           <a:xfrm>
-            <a:off x="1149351" y="2015732"/>
-            <a:ext cx="9905504" cy="3450613"/>
+            <a:off x="440267" y="2015732"/>
+            <a:ext cx="10614588" cy="3450613"/>
           </a:xfrm>
         </p:spPr>
         <p:txBody>
@@ -5528,12 +6774,644 @@
           <a:lstStyle/>
           <a:p>
             <a:r>
-              <a:rPr lang="fr-FR" sz="2400" dirty="0">
-                <a:latin typeface="Times New Roman" panose="02020603050405020304" pitchFamily="18" charset="0"/>
-                <a:cs typeface="Times New Roman" panose="02020603050405020304" pitchFamily="18" charset="0"/>
-              </a:rPr>
-              <a:t>“J’ai utilisé JavaScript pour gérer l’interactivité du site : dark mode, navbar dynamique, compteurs animés, filtrage et validation formulaire. Bootstrap m’a permis de créer une interface responsive avec des composants prêts à l’emploi. Enfin, j’ai utilisé du CSS avancé pour les animations, le responsive design et l’amélioration visuelle.”</a:t>
-            </a:r>
+              <a:rPr lang="fr-FR" sz="1800" b="1" dirty="0">
+                <a:solidFill>
+                  <a:schemeClr val="accent1">
+                    <a:lumMod val="60000"/>
+                    <a:lumOff val="40000"/>
+                  </a:schemeClr>
+                </a:solidFill>
+                <a:latin typeface="Times New Roman" panose="02020603050405020304" pitchFamily="18" charset="0"/>
+                <a:cs typeface="Times New Roman" panose="02020603050405020304" pitchFamily="18" charset="0"/>
+              </a:rPr>
+              <a:t>Le JavaScript a été utilisé pour ajouter de l’interactivité et améliorer</a:t>
+            </a:r>
+          </a:p>
+          <a:p>
+            <a:r>
+              <a:rPr lang="fr-FR" sz="1800" dirty="0">
+                <a:latin typeface="Times New Roman" panose="02020603050405020304" pitchFamily="18" charset="0"/>
+                <a:cs typeface="Times New Roman" panose="02020603050405020304" pitchFamily="18" charset="0"/>
+              </a:rPr>
+              <a:t> </a:t>
+            </a:r>
+            <a:r>
+              <a:rPr lang="fr-FR" sz="1800" b="1" dirty="0">
+                <a:solidFill>
+                  <a:schemeClr val="accent1">
+                    <a:lumMod val="60000"/>
+                    <a:lumOff val="40000"/>
+                  </a:schemeClr>
+                </a:solidFill>
+                <a:latin typeface="Times New Roman" panose="02020603050405020304" pitchFamily="18" charset="0"/>
+                <a:cs typeface="Times New Roman" panose="02020603050405020304" pitchFamily="18" charset="0"/>
+              </a:rPr>
+              <a:t>l’expérience utilisateur sur le site</a:t>
+            </a:r>
+            <a:r>
+              <a:rPr lang="fr-FR" sz="1800" dirty="0">
+                <a:latin typeface="Times New Roman" panose="02020603050405020304" pitchFamily="18" charset="0"/>
+                <a:cs typeface="Times New Roman" panose="02020603050405020304" pitchFamily="18" charset="0"/>
+              </a:rPr>
+              <a:t>.</a:t>
+            </a:r>
+          </a:p>
+          <a:p>
+            <a:r>
+              <a:rPr lang="fr-FR" sz="1800" b="1" dirty="0">
+                <a:latin typeface="Times New Roman" panose="02020603050405020304" pitchFamily="18" charset="0"/>
+                <a:cs typeface="Times New Roman" panose="02020603050405020304" pitchFamily="18" charset="0"/>
+              </a:rPr>
+              <a:t>Fonctionnalités développées :</a:t>
+            </a:r>
+          </a:p>
+          <a:p>
+            <a:r>
+              <a:rPr lang="fr-FR" sz="1800" dirty="0">
+                <a:latin typeface="Times New Roman" panose="02020603050405020304" pitchFamily="18" charset="0"/>
+                <a:cs typeface="Times New Roman" panose="02020603050405020304" pitchFamily="18" charset="0"/>
+              </a:rPr>
+              <a:t>• Activation du </a:t>
+            </a:r>
+            <a:r>
+              <a:rPr lang="fr-FR" sz="1800" b="1" dirty="0">
+                <a:latin typeface="Times New Roman" panose="02020603050405020304" pitchFamily="18" charset="0"/>
+                <a:cs typeface="Times New Roman" panose="02020603050405020304" pitchFamily="18" charset="0"/>
+              </a:rPr>
+              <a:t>mode sombre / clair</a:t>
+            </a:r>
+            <a:br>
+              <a:rPr lang="fr-FR" sz="1800" dirty="0">
+                <a:latin typeface="Times New Roman" panose="02020603050405020304" pitchFamily="18" charset="0"/>
+                <a:cs typeface="Times New Roman" panose="02020603050405020304" pitchFamily="18" charset="0"/>
+              </a:rPr>
+            </a:br>
+            <a:r>
+              <a:rPr lang="fr-FR" sz="1800" dirty="0">
+                <a:latin typeface="Times New Roman" panose="02020603050405020304" pitchFamily="18" charset="0"/>
+                <a:cs typeface="Times New Roman" panose="02020603050405020304" pitchFamily="18" charset="0"/>
+              </a:rPr>
+              <a:t>• Bouton </a:t>
+            </a:r>
+            <a:r>
+              <a:rPr lang="fr-FR" sz="1800" b="1" dirty="0">
+                <a:latin typeface="Times New Roman" panose="02020603050405020304" pitchFamily="18" charset="0"/>
+                <a:cs typeface="Times New Roman" panose="02020603050405020304" pitchFamily="18" charset="0"/>
+              </a:rPr>
+              <a:t>retour en haut</a:t>
+            </a:r>
+            <a:r>
+              <a:rPr lang="fr-FR" sz="1800" dirty="0">
+                <a:latin typeface="Times New Roman" panose="02020603050405020304" pitchFamily="18" charset="0"/>
+                <a:cs typeface="Times New Roman" panose="02020603050405020304" pitchFamily="18" charset="0"/>
+              </a:rPr>
+              <a:t> après défilement</a:t>
+            </a:r>
+            <a:br>
+              <a:rPr lang="fr-FR" sz="1800" dirty="0">
+                <a:latin typeface="Times New Roman" panose="02020603050405020304" pitchFamily="18" charset="0"/>
+                <a:cs typeface="Times New Roman" panose="02020603050405020304" pitchFamily="18" charset="0"/>
+              </a:rPr>
+            </a:br>
+            <a:r>
+              <a:rPr lang="fr-FR" sz="1800" dirty="0">
+                <a:latin typeface="Times New Roman" panose="02020603050405020304" pitchFamily="18" charset="0"/>
+                <a:cs typeface="Times New Roman" panose="02020603050405020304" pitchFamily="18" charset="0"/>
+              </a:rPr>
+              <a:t>• Animation automatique des </a:t>
+            </a:r>
+            <a:r>
+              <a:rPr lang="fr-FR" sz="1800" b="1" dirty="0">
+                <a:latin typeface="Times New Roman" panose="02020603050405020304" pitchFamily="18" charset="0"/>
+                <a:cs typeface="Times New Roman" panose="02020603050405020304" pitchFamily="18" charset="0"/>
+              </a:rPr>
+              <a:t>compteurs statistiques</a:t>
+            </a:r>
+            <a:br>
+              <a:rPr lang="fr-FR" sz="1800" dirty="0">
+                <a:latin typeface="Times New Roman" panose="02020603050405020304" pitchFamily="18" charset="0"/>
+                <a:cs typeface="Times New Roman" panose="02020603050405020304" pitchFamily="18" charset="0"/>
+              </a:rPr>
+            </a:br>
+            <a:r>
+              <a:rPr lang="fr-FR" sz="1800" dirty="0">
+                <a:latin typeface="Times New Roman" panose="02020603050405020304" pitchFamily="18" charset="0"/>
+                <a:cs typeface="Times New Roman" panose="02020603050405020304" pitchFamily="18" charset="0"/>
+              </a:rPr>
+              <a:t>• Validation du </a:t>
+            </a:r>
+            <a:r>
+              <a:rPr lang="fr-FR" sz="1800" b="1" dirty="0">
+                <a:latin typeface="Times New Roman" panose="02020603050405020304" pitchFamily="18" charset="0"/>
+                <a:cs typeface="Times New Roman" panose="02020603050405020304" pitchFamily="18" charset="0"/>
+              </a:rPr>
+              <a:t>formulaire de contact</a:t>
+            </a:r>
+            <a:br>
+              <a:rPr lang="fr-FR" sz="1800" dirty="0">
+                <a:latin typeface="Times New Roman" panose="02020603050405020304" pitchFamily="18" charset="0"/>
+                <a:cs typeface="Times New Roman" panose="02020603050405020304" pitchFamily="18" charset="0"/>
+              </a:rPr>
+            </a:br>
+            <a:r>
+              <a:rPr lang="fr-FR" sz="1800" dirty="0">
+                <a:latin typeface="Times New Roman" panose="02020603050405020304" pitchFamily="18" charset="0"/>
+                <a:cs typeface="Times New Roman" panose="02020603050405020304" pitchFamily="18" charset="0"/>
+              </a:rPr>
+              <a:t>• Filtrage dynamique des </a:t>
+            </a:r>
+            <a:r>
+              <a:rPr lang="fr-FR" sz="1800" b="1" dirty="0">
+                <a:latin typeface="Times New Roman" panose="02020603050405020304" pitchFamily="18" charset="0"/>
+                <a:cs typeface="Times New Roman" panose="02020603050405020304" pitchFamily="18" charset="0"/>
+              </a:rPr>
+              <a:t>profils freelances</a:t>
+            </a:r>
+            <a:endParaRPr lang="fr-FR" sz="1800" dirty="0">
+              <a:latin typeface="Times New Roman" panose="02020603050405020304" pitchFamily="18" charset="0"/>
+              <a:cs typeface="Times New Roman" panose="02020603050405020304" pitchFamily="18" charset="0"/>
+            </a:endParaRPr>
+          </a:p>
+          <a:p>
+            <a:endParaRPr lang="fr-FR" sz="1500" dirty="0">
+              <a:latin typeface="Times New Roman" panose="02020603050405020304" pitchFamily="18" charset="0"/>
+              <a:cs typeface="Times New Roman" panose="02020603050405020304" pitchFamily="18" charset="0"/>
+            </a:endParaRPr>
+          </a:p>
+        </p:txBody>
+      </p:sp>
+      <p:sp>
+        <p:nvSpPr>
+          <p:cNvPr id="8" name="ZoneTexte 7">
+            <a:extLst>
+              <a:ext uri="{FF2B5EF4-FFF2-40B4-BE49-F238E27FC236}">
+                <a16:creationId xmlns:a16="http://schemas.microsoft.com/office/drawing/2014/main" id="{D95B8091-3C2B-4930-844D-598EBF1409EA}"/>
+              </a:ext>
+            </a:extLst>
+          </p:cNvPr>
+          <p:cNvSpPr txBox="1"/>
+          <p:nvPr/>
+        </p:nvSpPr>
+        <p:spPr>
+          <a:xfrm flipH="1" flipV="1">
+            <a:off x="3996267" y="2253828"/>
+            <a:ext cx="7046382" cy="45719"/>
+          </a:xfrm>
+          <a:prstGeom prst="rect">
+            <a:avLst/>
+          </a:prstGeom>
+          <a:noFill/>
+        </p:spPr>
+        <p:txBody>
+          <a:bodyPr wrap="square" rtlCol="0">
+            <a:spAutoFit/>
+          </a:bodyPr>
+          <a:lstStyle/>
+          <a:p>
+            <a:endParaRPr lang="fr-FR" sz="1400" b="0" dirty="0">
+              <a:solidFill>
+                <a:srgbClr val="BBBEBF"/>
+              </a:solidFill>
+              <a:effectLst/>
+              <a:latin typeface="Consolas" panose="020B0609020204030204" pitchFamily="49" charset="0"/>
+            </a:endParaRPr>
+          </a:p>
+        </p:txBody>
+      </p:sp>
+      <p:sp>
+        <p:nvSpPr>
+          <p:cNvPr id="9" name="ZoneTexte 8">
+            <a:extLst>
+              <a:ext uri="{FF2B5EF4-FFF2-40B4-BE49-F238E27FC236}">
+                <a16:creationId xmlns:a16="http://schemas.microsoft.com/office/drawing/2014/main" id="{35B3CECF-60DB-4A13-9886-862AF005CC5D}"/>
+              </a:ext>
+            </a:extLst>
+          </p:cNvPr>
+          <p:cNvSpPr txBox="1"/>
+          <p:nvPr/>
+        </p:nvSpPr>
+        <p:spPr>
+          <a:xfrm>
+            <a:off x="7647515" y="7822354"/>
+            <a:ext cx="3816351" cy="369332"/>
+          </a:xfrm>
+          <a:prstGeom prst="rect">
+            <a:avLst/>
+          </a:prstGeom>
+          <a:noFill/>
+        </p:spPr>
+        <p:txBody>
+          <a:bodyPr wrap="square" rtlCol="0">
+            <a:spAutoFit/>
+          </a:bodyPr>
+          <a:lstStyle/>
+          <a:p>
+            <a:r>
+              <a:rPr lang="fr-FR" b="0" dirty="0">
+                <a:solidFill>
+                  <a:srgbClr val="C9D1D9"/>
+                </a:solidFill>
+                <a:effectLst/>
+                <a:latin typeface="Consolas" panose="020B0609020204030204" pitchFamily="49" charset="0"/>
+              </a:rPr>
+              <a:t>.</a:t>
+            </a:r>
+            <a:endParaRPr lang="fr-FR" dirty="0"/>
+          </a:p>
+        </p:txBody>
+      </p:sp>
+      <p:sp>
+        <p:nvSpPr>
+          <p:cNvPr id="11" name="ZoneTexte 10">
+            <a:extLst>
+              <a:ext uri="{FF2B5EF4-FFF2-40B4-BE49-F238E27FC236}">
+                <a16:creationId xmlns:a16="http://schemas.microsoft.com/office/drawing/2014/main" id="{439DC7F7-8F3E-42DD-AFDB-B7551708FAF3}"/>
+              </a:ext>
+            </a:extLst>
+          </p:cNvPr>
+          <p:cNvSpPr txBox="1"/>
+          <p:nvPr/>
+        </p:nvSpPr>
+        <p:spPr>
+          <a:xfrm>
+            <a:off x="7112000" y="2253828"/>
+            <a:ext cx="3056467" cy="3693319"/>
+          </a:xfrm>
+          <a:prstGeom prst="rect">
+            <a:avLst/>
+          </a:prstGeom>
+          <a:noFill/>
+        </p:spPr>
+        <p:txBody>
+          <a:bodyPr wrap="square" rtlCol="0">
+            <a:spAutoFit/>
+          </a:bodyPr>
+          <a:lstStyle/>
+          <a:p>
+            <a:r>
+              <a:rPr lang="en-US" b="0" dirty="0">
+                <a:solidFill>
+                  <a:srgbClr val="FF7B72"/>
+                </a:solidFill>
+                <a:effectLst/>
+                <a:latin typeface="Consolas" panose="020B0609020204030204" pitchFamily="49" charset="0"/>
+              </a:rPr>
+              <a:t>const</a:t>
+            </a:r>
+            <a:r>
+              <a:rPr lang="en-US" b="0" dirty="0">
+                <a:solidFill>
+                  <a:srgbClr val="BBBEBF"/>
+                </a:solidFill>
+                <a:effectLst/>
+                <a:latin typeface="Consolas" panose="020B0609020204030204" pitchFamily="49" charset="0"/>
+              </a:rPr>
+              <a:t> </a:t>
+            </a:r>
+            <a:r>
+              <a:rPr lang="en-US" b="0" dirty="0">
+                <a:solidFill>
+                  <a:srgbClr val="79C0FF"/>
+                </a:solidFill>
+                <a:effectLst/>
+                <a:latin typeface="Consolas" panose="020B0609020204030204" pitchFamily="49" charset="0"/>
+              </a:rPr>
+              <a:t>themeToggle</a:t>
+            </a:r>
+            <a:r>
+              <a:rPr lang="en-US" b="0" dirty="0">
+                <a:solidFill>
+                  <a:srgbClr val="BBBEBF"/>
+                </a:solidFill>
+                <a:effectLst/>
+                <a:latin typeface="Consolas" panose="020B0609020204030204" pitchFamily="49" charset="0"/>
+              </a:rPr>
+              <a:t> </a:t>
+            </a:r>
+            <a:r>
+              <a:rPr lang="en-US" b="0" dirty="0">
+                <a:solidFill>
+                  <a:srgbClr val="D4D4D4"/>
+                </a:solidFill>
+                <a:effectLst/>
+                <a:latin typeface="Consolas" panose="020B0609020204030204" pitchFamily="49" charset="0"/>
+              </a:rPr>
+              <a:t>=</a:t>
+            </a:r>
+            <a:r>
+              <a:rPr lang="en-US" b="0" dirty="0">
+                <a:solidFill>
+                  <a:srgbClr val="BBBEBF"/>
+                </a:solidFill>
+                <a:effectLst/>
+                <a:latin typeface="Consolas" panose="020B0609020204030204" pitchFamily="49" charset="0"/>
+              </a:rPr>
+              <a:t> </a:t>
+            </a:r>
+            <a:r>
+              <a:rPr lang="en-US" b="0" dirty="0">
+                <a:solidFill>
+                  <a:srgbClr val="79C0FF"/>
+                </a:solidFill>
+                <a:effectLst/>
+                <a:latin typeface="Consolas" panose="020B0609020204030204" pitchFamily="49" charset="0"/>
+              </a:rPr>
+              <a:t>document</a:t>
+            </a:r>
+            <a:r>
+              <a:rPr lang="en-US" b="0" dirty="0">
+                <a:solidFill>
+                  <a:srgbClr val="BBBEBF"/>
+                </a:solidFill>
+                <a:effectLst/>
+                <a:latin typeface="Consolas" panose="020B0609020204030204" pitchFamily="49" charset="0"/>
+              </a:rPr>
+              <a:t>.</a:t>
+            </a:r>
+            <a:r>
+              <a:rPr lang="en-US" b="0" dirty="0">
+                <a:solidFill>
+                  <a:srgbClr val="D2A8FF"/>
+                </a:solidFill>
+                <a:effectLst/>
+                <a:latin typeface="Consolas" panose="020B0609020204030204" pitchFamily="49" charset="0"/>
+              </a:rPr>
+              <a:t>getElementByd</a:t>
+            </a:r>
+            <a:r>
+              <a:rPr lang="en-US" b="0" dirty="0">
+                <a:solidFill>
+                  <a:srgbClr val="BBBEBF"/>
+                </a:solidFill>
+                <a:effectLst/>
+                <a:latin typeface="Consolas" panose="020B0609020204030204" pitchFamily="49" charset="0"/>
+              </a:rPr>
+              <a:t>(</a:t>
+            </a:r>
+            <a:r>
+              <a:rPr lang="en-US" b="0" dirty="0">
+                <a:solidFill>
+                  <a:srgbClr val="A5D6FF"/>
+                </a:solidFill>
+                <a:effectLst/>
+                <a:latin typeface="Consolas" panose="020B0609020204030204" pitchFamily="49" charset="0"/>
+              </a:rPr>
+              <a:t>"theme-toggle"</a:t>
+            </a:r>
+            <a:r>
+              <a:rPr lang="en-US" b="0" dirty="0">
+                <a:solidFill>
+                  <a:srgbClr val="BBBEBF"/>
+                </a:solidFill>
+                <a:effectLst/>
+                <a:latin typeface="Consolas" panose="020B0609020204030204" pitchFamily="49" charset="0"/>
+              </a:rPr>
+              <a:t>);</a:t>
+            </a:r>
+          </a:p>
+          <a:p>
+            <a:r>
+              <a:rPr lang="en-US" b="0" dirty="0">
+                <a:solidFill>
+                  <a:srgbClr val="79C0FF"/>
+                </a:solidFill>
+                <a:effectLst/>
+                <a:latin typeface="Consolas" panose="020B0609020204030204" pitchFamily="49" charset="0"/>
+              </a:rPr>
+              <a:t>themeToggle</a:t>
+            </a:r>
+            <a:r>
+              <a:rPr lang="en-US" b="0" dirty="0">
+                <a:solidFill>
+                  <a:srgbClr val="C9D1D9"/>
+                </a:solidFill>
+                <a:effectLst/>
+                <a:latin typeface="Consolas" panose="020B0609020204030204" pitchFamily="49" charset="0"/>
+              </a:rPr>
+              <a:t>.</a:t>
+            </a:r>
+            <a:r>
+              <a:rPr lang="en-US" b="0" dirty="0">
+                <a:solidFill>
+                  <a:srgbClr val="D2A8FF"/>
+                </a:solidFill>
+                <a:effectLst/>
+                <a:latin typeface="Consolas" panose="020B0609020204030204" pitchFamily="49" charset="0"/>
+              </a:rPr>
+              <a:t>addEventListener</a:t>
+            </a:r>
+            <a:r>
+              <a:rPr lang="en-US" b="0" dirty="0">
+                <a:solidFill>
+                  <a:srgbClr val="C9D1D9"/>
+                </a:solidFill>
+                <a:effectLst/>
+                <a:latin typeface="Consolas" panose="020B0609020204030204" pitchFamily="49" charset="0"/>
+              </a:rPr>
+              <a:t>(</a:t>
+            </a:r>
+            <a:r>
+              <a:rPr lang="en-US" b="0" dirty="0">
+                <a:solidFill>
+                  <a:srgbClr val="A5D6FF"/>
+                </a:solidFill>
+                <a:effectLst/>
+                <a:latin typeface="Consolas" panose="020B0609020204030204" pitchFamily="49" charset="0"/>
+              </a:rPr>
+              <a:t>"click"</a:t>
+            </a:r>
+            <a:r>
+              <a:rPr lang="en-US" b="0" dirty="0">
+                <a:solidFill>
+                  <a:srgbClr val="C9D1D9"/>
+                </a:solidFill>
+                <a:effectLst/>
+                <a:latin typeface="Consolas" panose="020B0609020204030204" pitchFamily="49" charset="0"/>
+              </a:rPr>
+              <a:t>, </a:t>
+            </a:r>
+            <a:r>
+              <a:rPr lang="en-US" b="0" dirty="0">
+                <a:solidFill>
+                  <a:srgbClr val="FF7B72"/>
+                </a:solidFill>
+                <a:effectLst/>
+                <a:latin typeface="Consolas" panose="020B0609020204030204" pitchFamily="49" charset="0"/>
+              </a:rPr>
+              <a:t>function</a:t>
+            </a:r>
+            <a:r>
+              <a:rPr lang="en-US" b="0" dirty="0">
+                <a:solidFill>
+                  <a:srgbClr val="C9D1D9"/>
+                </a:solidFill>
+                <a:effectLst/>
+                <a:latin typeface="Consolas" panose="020B0609020204030204" pitchFamily="49" charset="0"/>
+              </a:rPr>
+              <a:t> () {</a:t>
+            </a:r>
+            <a:endParaRPr lang="en-US" b="0" dirty="0">
+              <a:solidFill>
+                <a:srgbClr val="BBBEBF"/>
+              </a:solidFill>
+              <a:effectLst/>
+              <a:latin typeface="Consolas" panose="020B0609020204030204" pitchFamily="49" charset="0"/>
+            </a:endParaRPr>
+          </a:p>
+          <a:p>
+            <a:r>
+              <a:rPr lang="en-US" b="0" dirty="0">
+                <a:solidFill>
+                  <a:srgbClr val="C9D1D9"/>
+                </a:solidFill>
+                <a:effectLst/>
+                <a:latin typeface="Consolas" panose="020B0609020204030204" pitchFamily="49" charset="0"/>
+              </a:rPr>
+              <a:t>        </a:t>
+            </a:r>
+            <a:r>
+              <a:rPr lang="en-US" b="0" dirty="0">
+                <a:solidFill>
+                  <a:srgbClr val="79C0FF"/>
+                </a:solidFill>
+                <a:effectLst/>
+                <a:latin typeface="Consolas" panose="020B0609020204030204" pitchFamily="49" charset="0"/>
+              </a:rPr>
+              <a:t>document</a:t>
+            </a:r>
+            <a:r>
+              <a:rPr lang="en-US" b="0" dirty="0">
+                <a:solidFill>
+                  <a:srgbClr val="C9D1D9"/>
+                </a:solidFill>
+                <a:effectLst/>
+                <a:latin typeface="Consolas" panose="020B0609020204030204" pitchFamily="49" charset="0"/>
+              </a:rPr>
+              <a:t>.</a:t>
+            </a:r>
+            <a:r>
+              <a:rPr lang="en-US" b="0" dirty="0">
+                <a:solidFill>
+                  <a:srgbClr val="79C0FF"/>
+                </a:solidFill>
+                <a:effectLst/>
+                <a:latin typeface="Consolas" panose="020B0609020204030204" pitchFamily="49" charset="0"/>
+              </a:rPr>
+              <a:t>body</a:t>
+            </a:r>
+            <a:r>
+              <a:rPr lang="en-US" b="0" dirty="0">
+                <a:solidFill>
+                  <a:srgbClr val="C9D1D9"/>
+                </a:solidFill>
+                <a:effectLst/>
+                <a:latin typeface="Consolas" panose="020B0609020204030204" pitchFamily="49" charset="0"/>
+              </a:rPr>
+              <a:t>.</a:t>
+            </a:r>
+            <a:r>
+              <a:rPr lang="en-US" b="0" dirty="0">
+                <a:solidFill>
+                  <a:srgbClr val="79C0FF"/>
+                </a:solidFill>
+                <a:effectLst/>
+                <a:latin typeface="Consolas" panose="020B0609020204030204" pitchFamily="49" charset="0"/>
+              </a:rPr>
+              <a:t>classList</a:t>
+            </a:r>
+            <a:r>
+              <a:rPr lang="en-US" b="0" dirty="0">
+                <a:solidFill>
+                  <a:srgbClr val="C9D1D9"/>
+                </a:solidFill>
+                <a:effectLst/>
+                <a:latin typeface="Consolas" panose="020B0609020204030204" pitchFamily="49" charset="0"/>
+              </a:rPr>
+              <a:t>.</a:t>
+            </a:r>
+            <a:r>
+              <a:rPr lang="en-US" b="0" dirty="0">
+                <a:solidFill>
+                  <a:srgbClr val="D2A8FF"/>
+                </a:solidFill>
+                <a:effectLst/>
+                <a:latin typeface="Consolas" panose="020B0609020204030204" pitchFamily="49" charset="0"/>
+              </a:rPr>
+              <a:t>toggle</a:t>
+            </a:r>
+            <a:r>
+              <a:rPr lang="en-US" b="0" dirty="0">
+                <a:solidFill>
+                  <a:srgbClr val="C9D1D9"/>
+                </a:solidFill>
+                <a:effectLst/>
+                <a:latin typeface="Consolas" panose="020B0609020204030204" pitchFamily="49" charset="0"/>
+              </a:rPr>
+              <a:t>(</a:t>
+            </a:r>
+            <a:r>
+              <a:rPr lang="en-US" b="0" dirty="0">
+                <a:solidFill>
+                  <a:srgbClr val="A5D6FF"/>
+                </a:solidFill>
+                <a:effectLst/>
+                <a:latin typeface="Consolas" panose="020B0609020204030204" pitchFamily="49" charset="0"/>
+              </a:rPr>
+              <a:t>"dark-mode"</a:t>
+            </a:r>
+            <a:r>
+              <a:rPr lang="en-US" b="0" dirty="0">
+                <a:solidFill>
+                  <a:srgbClr val="C9D1D9"/>
+                </a:solidFill>
+                <a:effectLst/>
+                <a:latin typeface="Consolas" panose="020B0609020204030204" pitchFamily="49" charset="0"/>
+              </a:rPr>
+              <a:t>);</a:t>
+            </a:r>
+            <a:endParaRPr lang="en-US" b="0" dirty="0">
+              <a:solidFill>
+                <a:srgbClr val="BBBEBF"/>
+              </a:solidFill>
+              <a:effectLst/>
+              <a:latin typeface="Consolas" panose="020B0609020204030204" pitchFamily="49" charset="0"/>
+            </a:endParaRPr>
+          </a:p>
+          <a:p>
+            <a:endParaRPr lang="en-US" b="0" dirty="0">
+              <a:solidFill>
+                <a:srgbClr val="BBBEBF"/>
+              </a:solidFill>
+              <a:effectLst/>
+              <a:latin typeface="Consolas" panose="020B0609020204030204" pitchFamily="49" charset="0"/>
+            </a:endParaRPr>
+          </a:p>
+          <a:p>
+            <a:endParaRPr lang="en-US" b="0" dirty="0">
+              <a:solidFill>
+                <a:srgbClr val="BBBEBF"/>
+              </a:solidFill>
+              <a:effectLst/>
+              <a:latin typeface="Consolas" panose="020B0609020204030204" pitchFamily="49" charset="0"/>
+            </a:endParaRPr>
+          </a:p>
+          <a:p>
+            <a:endParaRPr lang="en-US" b="0" dirty="0">
+              <a:solidFill>
+                <a:srgbClr val="BBBEBF"/>
+              </a:solidFill>
+              <a:effectLst/>
+              <a:latin typeface="Consolas" panose="020B0609020204030204" pitchFamily="49" charset="0"/>
+            </a:endParaRPr>
+          </a:p>
+          <a:p>
+            <a:endParaRPr lang="en-US" b="0" dirty="0">
+              <a:solidFill>
+                <a:srgbClr val="BBBEBF"/>
+              </a:solidFill>
+              <a:effectLst/>
+              <a:latin typeface="Consolas" panose="020B0609020204030204" pitchFamily="49" charset="0"/>
+            </a:endParaRPr>
           </a:p>
         </p:txBody>
       </p:sp>
@@ -5572,7 +7450,7 @@
           <p:cNvPr id="2" name="Titre 1">
             <a:extLst>
               <a:ext uri="{FF2B5EF4-FFF2-40B4-BE49-F238E27FC236}">
-                <a16:creationId xmlns:a16="http://schemas.microsoft.com/office/drawing/2014/main" id="{FD1FA03B-EC0F-4BEF-B66A-ABD00BB1AE7D}"/>
+                <a16:creationId xmlns:a16="http://schemas.microsoft.com/office/drawing/2014/main" id="{E4EB0360-51DF-49C0-ABDC-C758C7129511}"/>
               </a:ext>
             </a:extLst>
           </p:cNvPr>
@@ -5583,492 +7461,152 @@
             <p:ph type="title"/>
           </p:nvPr>
         </p:nvSpPr>
-        <p:spPr>
-          <a:xfrm>
-            <a:off x="1076929" y="163169"/>
-            <a:ext cx="9603275" cy="1430681"/>
-          </a:xfrm>
-        </p:spPr>
+        <p:spPr/>
         <p:txBody>
           <a:bodyPr>
-            <a:noAutofit/>
+            <a:normAutofit fontScale="90000"/>
           </a:bodyPr>
           <a:lstStyle/>
           <a:p>
             <a:pPr algn="ctr"/>
             <a:r>
-              <a:rPr lang="en-US" sz="4800" b="1" dirty="0"/>
-              <a:t> DIFFiCULTEs RENCONTRE ET SOLUTIONs</a:t>
-            </a:r>
-            <a:endParaRPr lang="fr-FR" sz="4800" b="1" dirty="0"/>
-          </a:p>
-        </p:txBody>
-      </p:sp>
-      <p:sp>
-        <p:nvSpPr>
-          <p:cNvPr id="4" name="Rectangle 1">
+              <a:rPr lang="fr-FR" sz="4000" b="0" i="0" dirty="0">
+                <a:effectLst/>
+                <a:latin typeface="Arial Black" panose="020B0A04020102020204" pitchFamily="34" charset="0"/>
+              </a:rPr>
+              <a:t>Bootstrap (composants utilisés)</a:t>
+            </a:r>
+            <a:r>
+              <a:rPr lang="fr-FR" sz="4000" dirty="0">
+                <a:latin typeface="Arial Black" panose="020B0A04020102020204" pitchFamily="34" charset="0"/>
+              </a:rPr>
+              <a:t> </a:t>
+            </a:r>
+            <a:br>
+              <a:rPr lang="fr-FR" dirty="0"/>
+            </a:br>
+            <a:endParaRPr lang="fr-FR" dirty="0"/>
+          </a:p>
+        </p:txBody>
+      </p:sp>
+      <p:sp>
+        <p:nvSpPr>
+          <p:cNvPr id="3" name="Espace réservé du contenu 2">
             <a:extLst>
               <a:ext uri="{FF2B5EF4-FFF2-40B4-BE49-F238E27FC236}">
-                <a16:creationId xmlns:a16="http://schemas.microsoft.com/office/drawing/2014/main" id="{6D16FAED-D4ED-4283-BFF7-7E52EB09EC71}"/>
+                <a16:creationId xmlns:a16="http://schemas.microsoft.com/office/drawing/2014/main" id="{5EB68799-EAC4-4D81-8CD1-CB2439B061DB}"/>
               </a:ext>
             </a:extLst>
           </p:cNvPr>
           <p:cNvSpPr>
-            <a:spLocks noGrp="1" noChangeArrowheads="1"/>
+            <a:spLocks noGrp="1"/>
           </p:cNvSpPr>
           <p:nvPr>
             <p:ph idx="1"/>
           </p:nvPr>
         </p:nvSpPr>
-        <p:spPr bwMode="auto">
+        <p:spPr>
           <a:xfrm>
-            <a:off x="1150577" y="2020179"/>
-            <a:ext cx="4378122" cy="3416320"/>
+            <a:off x="1451579" y="2175933"/>
+            <a:ext cx="9603275" cy="3290412"/>
           </a:xfrm>
-          <a:prstGeom prst="rect">
-            <a:avLst/>
-          </a:prstGeom>
-          <a:noFill/>
-          <a:ln>
-            <a:noFill/>
-          </a:ln>
-          <a:effectLst/>
-          <a:extLst>
-            <a:ext uri="{909E8E84-426E-40DD-AFC4-6F175D3DCCD1}">
-              <a14:hiddenFill xmlns:a14="http://schemas.microsoft.com/office/drawing/2010/main">
-                <a:solidFill>
-                  <a:schemeClr val="accent1"/>
-                </a:solidFill>
-              </a14:hiddenFill>
-            </a:ext>
-            <a:ext uri="{91240B29-F687-4F45-9708-019B960494DF}">
-              <a14:hiddenLine xmlns:a14="http://schemas.microsoft.com/office/drawing/2010/main" w="9525">
-                <a:solidFill>
-                  <a:schemeClr val="tx1"/>
-                </a:solidFill>
-                <a:miter lim="800000"/>
-                <a:headEnd/>
-                <a:tailEnd/>
-              </a14:hiddenLine>
-            </a:ext>
-            <a:ext uri="{AF507438-7753-43E0-B8FC-AC1667EBCBE1}">
-              <a14:hiddenEffects xmlns:a14="http://schemas.microsoft.com/office/drawing/2010/main">
-                <a:effectLst>
-                  <a:outerShdw dist="35921" dir="2700000" algn="ctr" rotWithShape="0">
-                    <a:schemeClr val="bg2"/>
-                  </a:outerShdw>
-                </a:effectLst>
-              </a14:hiddenEffects>
-            </a:ext>
-          </a:extLst>
         </p:spPr>
         <p:txBody>
-          <a:bodyPr vert="horz" wrap="none" lIns="91440" tIns="45720" rIns="91440" bIns="45720" numCol="1" anchor="ctr" anchorCtr="0" compatLnSpc="1">
-            <a:prstTxWarp prst="textNoShape">
-              <a:avLst/>
-            </a:prstTxWarp>
-            <a:spAutoFit/>
+          <a:bodyPr>
+            <a:normAutofit fontScale="77500" lnSpcReduction="20000"/>
           </a:bodyPr>
           <a:lstStyle/>
           <a:p>
-            <a:pPr marL="0" marR="0" lvl="0" indent="0" algn="just" defTabSz="914400" rtl="0" eaLnBrk="0" fontAlgn="base" latinLnBrk="0" hangingPunct="0">
-              <a:lnSpc>
-                <a:spcPct val="100000"/>
-              </a:lnSpc>
-              <a:spcBef>
-                <a:spcPct val="0"/>
-              </a:spcBef>
-              <a:spcAft>
-                <a:spcPct val="0"/>
-              </a:spcAft>
-              <a:buClrTx/>
-              <a:buSzTx/>
-              <a:buFontTx/>
-              <a:buNone/>
-              <a:tabLst/>
-            </a:pPr>
-            <a:r>
-              <a:rPr kumimoji="0" lang="fr-FR" altLang="fr-FR" sz="1800" b="0" i="0" u="none" strike="noStrike" cap="none" normalizeH="0" baseline="0" dirty="0">
-                <a:ln>
-                  <a:noFill/>
-                </a:ln>
-                <a:solidFill>
-                  <a:schemeClr val="tx1"/>
-                </a:solidFill>
-                <a:effectLst/>
-                <a:latin typeface="Times New Roman" panose="02020603050405020304" pitchFamily="18" charset="0"/>
-                <a:cs typeface="Times New Roman" panose="02020603050405020304" pitchFamily="18" charset="0"/>
-              </a:rPr>
-              <a:t>-Les difficultes rencontre</a:t>
-            </a:r>
-          </a:p>
-          <a:p>
-            <a:pPr marL="0" marR="0" lvl="0" indent="0" algn="just" defTabSz="914400" rtl="0" eaLnBrk="0" fontAlgn="base" latinLnBrk="0" hangingPunct="0">
-              <a:lnSpc>
-                <a:spcPct val="100000"/>
-              </a:lnSpc>
-              <a:spcBef>
-                <a:spcPct val="0"/>
-              </a:spcBef>
-              <a:spcAft>
-                <a:spcPct val="0"/>
-              </a:spcAft>
-              <a:buClrTx/>
-              <a:buSzTx/>
-              <a:buFontTx/>
-              <a:buChar char="•"/>
-              <a:tabLst/>
-            </a:pPr>
-            <a:r>
-              <a:rPr kumimoji="0" lang="fr-FR" altLang="fr-FR" sz="1800" b="0" i="0" u="none" strike="noStrike" cap="none" normalizeH="0" baseline="0" dirty="0">
-                <a:ln>
-                  <a:noFill/>
-                </a:ln>
-                <a:solidFill>
-                  <a:schemeClr val="tx1"/>
-                </a:solidFill>
-                <a:effectLst/>
-                <a:latin typeface="Times New Roman" panose="02020603050405020304" pitchFamily="18" charset="0"/>
-                <a:cs typeface="Times New Roman" panose="02020603050405020304" pitchFamily="18" charset="0"/>
-              </a:rPr>
-              <a:t>balise &lt;section&gt; non fermée </a:t>
-            </a:r>
-          </a:p>
-          <a:p>
-            <a:pPr marL="0" marR="0" lvl="0" indent="0" algn="just" defTabSz="914400" rtl="0" eaLnBrk="0" fontAlgn="base" latinLnBrk="0" hangingPunct="0">
-              <a:lnSpc>
-                <a:spcPct val="100000"/>
-              </a:lnSpc>
-              <a:spcBef>
-                <a:spcPct val="0"/>
-              </a:spcBef>
-              <a:spcAft>
-                <a:spcPct val="0"/>
-              </a:spcAft>
-              <a:buClrTx/>
-              <a:buSzTx/>
-              <a:buFontTx/>
-              <a:buChar char="•"/>
-              <a:tabLst/>
-            </a:pPr>
-            <a:r>
-              <a:rPr lang="fr-FR" altLang="fr-FR" sz="1800" dirty="0">
-                <a:latin typeface="Times New Roman" panose="02020603050405020304" pitchFamily="18" charset="0"/>
-                <a:cs typeface="Times New Roman" panose="02020603050405020304" pitchFamily="18" charset="0"/>
-              </a:rPr>
-              <a:t>Erreur des images</a:t>
-            </a:r>
-            <a:endParaRPr kumimoji="0" lang="fr-FR" altLang="fr-FR" sz="1800" b="0" i="0" u="none" strike="noStrike" cap="none" normalizeH="0" baseline="0" dirty="0">
-              <a:ln>
-                <a:noFill/>
-              </a:ln>
-              <a:solidFill>
-                <a:schemeClr val="tx1"/>
-              </a:solidFill>
-              <a:effectLst/>
-              <a:latin typeface="Times New Roman" panose="02020603050405020304" pitchFamily="18" charset="0"/>
-              <a:cs typeface="Times New Roman" panose="02020603050405020304" pitchFamily="18" charset="0"/>
-            </a:endParaRPr>
-          </a:p>
-          <a:p>
-            <a:pPr marL="0" marR="0" lvl="0" indent="0" algn="just" defTabSz="914400" rtl="0" eaLnBrk="0" fontAlgn="base" latinLnBrk="0" hangingPunct="0">
-              <a:lnSpc>
-                <a:spcPct val="100000"/>
-              </a:lnSpc>
-              <a:spcBef>
-                <a:spcPct val="0"/>
-              </a:spcBef>
-              <a:spcAft>
-                <a:spcPct val="0"/>
-              </a:spcAft>
-              <a:buClrTx/>
-              <a:buSzTx/>
-              <a:buFontTx/>
-              <a:buChar char="•"/>
-              <a:tabLst/>
-            </a:pPr>
-            <a:r>
-              <a:rPr kumimoji="0" lang="fr-FR" altLang="fr-FR" sz="1800" b="0" i="0" u="none" strike="noStrike" cap="none" normalizeH="0" baseline="0" dirty="0">
-                <a:ln>
-                  <a:noFill/>
-                </a:ln>
-                <a:solidFill>
-                  <a:schemeClr val="tx1"/>
-                </a:solidFill>
-                <a:effectLst/>
-                <a:latin typeface="Times New Roman" panose="02020603050405020304" pitchFamily="18" charset="0"/>
-                <a:cs typeface="Times New Roman" panose="02020603050405020304" pitchFamily="18" charset="0"/>
-              </a:rPr>
-              <a:t>commentaire HTML mal fermé </a:t>
-            </a:r>
-          </a:p>
-          <a:p>
-            <a:pPr marL="0" marR="0" lvl="0" indent="0" algn="just" defTabSz="914400" rtl="0" eaLnBrk="0" fontAlgn="base" latinLnBrk="0" hangingPunct="0">
-              <a:lnSpc>
-                <a:spcPct val="100000"/>
-              </a:lnSpc>
-              <a:spcBef>
-                <a:spcPct val="0"/>
-              </a:spcBef>
-              <a:spcAft>
-                <a:spcPct val="0"/>
-              </a:spcAft>
-              <a:buClrTx/>
-              <a:buSzTx/>
-              <a:buFontTx/>
-              <a:buChar char="•"/>
-              <a:tabLst/>
-            </a:pPr>
-            <a:r>
-              <a:rPr kumimoji="0" lang="fr-FR" altLang="fr-FR" sz="1800" b="0" i="0" u="none" strike="noStrike" cap="none" normalizeH="0" baseline="0" dirty="0">
-                <a:ln>
-                  <a:noFill/>
-                </a:ln>
-                <a:solidFill>
-                  <a:schemeClr val="tx1"/>
-                </a:solidFill>
-                <a:effectLst/>
-                <a:latin typeface="Times New Roman" panose="02020603050405020304" pitchFamily="18" charset="0"/>
-                <a:cs typeface="Times New Roman" panose="02020603050405020304" pitchFamily="18" charset="0"/>
-              </a:rPr>
-              <a:t>erreur dans le lien </a:t>
-            </a:r>
-          </a:p>
-          <a:p>
-            <a:pPr marL="0" marR="0" lvl="0" indent="0" algn="just" defTabSz="914400" rtl="0" eaLnBrk="0" fontAlgn="base" latinLnBrk="0" hangingPunct="0">
-              <a:lnSpc>
-                <a:spcPct val="100000"/>
-              </a:lnSpc>
-              <a:spcBef>
-                <a:spcPct val="0"/>
-              </a:spcBef>
-              <a:spcAft>
-                <a:spcPct val="0"/>
-              </a:spcAft>
-              <a:buClrTx/>
-              <a:buSzTx/>
-              <a:buNone/>
-              <a:tabLst/>
-            </a:pPr>
-            <a:r>
-              <a:rPr kumimoji="0" lang="fr-FR" altLang="fr-FR" sz="1800" b="0" i="0" u="none" strike="noStrike" cap="none" normalizeH="0" baseline="0" dirty="0">
-                <a:ln>
-                  <a:noFill/>
-                </a:ln>
-                <a:solidFill>
-                  <a:schemeClr val="tx1"/>
-                </a:solidFill>
-                <a:effectLst/>
-                <a:latin typeface="Times New Roman" panose="02020603050405020304" pitchFamily="18" charset="0"/>
-                <a:cs typeface="Times New Roman" panose="02020603050405020304" pitchFamily="18" charset="0"/>
-              </a:rPr>
-              <a:t>-Les Solutions</a:t>
-            </a:r>
-          </a:p>
-          <a:p>
-            <a:pPr marL="0" marR="0" lvl="0" indent="0" algn="just" defTabSz="914400" rtl="0" eaLnBrk="0" fontAlgn="base" latinLnBrk="0" hangingPunct="0">
-              <a:lnSpc>
-                <a:spcPct val="100000"/>
-              </a:lnSpc>
-              <a:spcBef>
-                <a:spcPct val="0"/>
-              </a:spcBef>
-              <a:spcAft>
-                <a:spcPct val="0"/>
-              </a:spcAft>
-              <a:buClrTx/>
-              <a:buSzTx/>
-              <a:buNone/>
-              <a:tabLst/>
-            </a:pPr>
-            <a:r>
-              <a:rPr kumimoji="0" lang="fr-FR" altLang="fr-FR" sz="1800" b="0" i="0" u="none" strike="noStrike" cap="none" normalizeH="0" baseline="0" dirty="0">
-                <a:ln>
-                  <a:noFill/>
-                </a:ln>
-                <a:solidFill>
-                  <a:schemeClr val="tx1"/>
-                </a:solidFill>
-                <a:effectLst/>
-                <a:latin typeface="Times New Roman" panose="02020603050405020304" pitchFamily="18" charset="0"/>
-                <a:cs typeface="Times New Roman" panose="02020603050405020304" pitchFamily="18" charset="0"/>
-              </a:rPr>
-              <a:t>.Verification ligne par ligne du code</a:t>
-            </a:r>
-          </a:p>
-          <a:p>
-            <a:pPr marL="0" marR="0" lvl="0" indent="0" algn="just" defTabSz="914400" rtl="0" eaLnBrk="0" fontAlgn="base" latinLnBrk="0" hangingPunct="0">
-              <a:lnSpc>
-                <a:spcPct val="100000"/>
-              </a:lnSpc>
-              <a:spcBef>
-                <a:spcPct val="0"/>
-              </a:spcBef>
-              <a:spcAft>
-                <a:spcPct val="0"/>
-              </a:spcAft>
-              <a:buClrTx/>
-              <a:buSzTx/>
-              <a:buNone/>
-              <a:tabLst/>
-            </a:pPr>
-            <a:r>
-              <a:rPr lang="fr-FR" altLang="fr-FR" sz="1800" dirty="0">
-                <a:latin typeface="Times New Roman" panose="02020603050405020304" pitchFamily="18" charset="0"/>
-                <a:cs typeface="Times New Roman" panose="02020603050405020304" pitchFamily="18" charset="0"/>
-              </a:rPr>
-              <a:t>.Verification des images</a:t>
-            </a:r>
-          </a:p>
-          <a:p>
-            <a:pPr marL="0" marR="0" lvl="0" indent="0" algn="just" defTabSz="914400" rtl="0" eaLnBrk="0" fontAlgn="base" latinLnBrk="0" hangingPunct="0">
-              <a:lnSpc>
-                <a:spcPct val="100000"/>
-              </a:lnSpc>
-              <a:spcBef>
-                <a:spcPct val="0"/>
-              </a:spcBef>
-              <a:spcAft>
-                <a:spcPct val="0"/>
-              </a:spcAft>
-              <a:buClrTx/>
-              <a:buSzTx/>
-              <a:buNone/>
-              <a:tabLst/>
-            </a:pPr>
-            <a:r>
-              <a:rPr kumimoji="0" lang="fr-FR" altLang="fr-FR" sz="1800" b="0" i="0" u="none" strike="noStrike" cap="none" normalizeH="0" baseline="0" dirty="0">
-                <a:ln>
-                  <a:noFill/>
-                </a:ln>
-                <a:solidFill>
-                  <a:schemeClr val="tx1"/>
-                </a:solidFill>
-                <a:effectLst/>
-                <a:latin typeface="Times New Roman" panose="02020603050405020304" pitchFamily="18" charset="0"/>
-                <a:cs typeface="Times New Roman" panose="02020603050405020304" pitchFamily="18" charset="0"/>
-              </a:rPr>
-              <a:t>.</a:t>
-            </a:r>
-            <a:r>
-              <a:rPr lang="fr-FR" altLang="fr-FR" sz="1800" dirty="0">
-                <a:latin typeface="Times New Roman" panose="02020603050405020304" pitchFamily="18" charset="0"/>
-                <a:cs typeface="Times New Roman" panose="02020603050405020304" pitchFamily="18" charset="0"/>
-              </a:rPr>
-              <a:t>Correction des balises ouvertes /non fermées</a:t>
-            </a:r>
-          </a:p>
-          <a:p>
-            <a:pPr marL="0" marR="0" lvl="0" indent="0" algn="just" defTabSz="914400" rtl="0" eaLnBrk="0" fontAlgn="base" latinLnBrk="0" hangingPunct="0">
-              <a:lnSpc>
-                <a:spcPct val="100000"/>
-              </a:lnSpc>
-              <a:spcBef>
-                <a:spcPct val="0"/>
-              </a:spcBef>
-              <a:spcAft>
-                <a:spcPct val="0"/>
-              </a:spcAft>
-              <a:buClrTx/>
-              <a:buSzTx/>
-              <a:buNone/>
-              <a:tabLst/>
-            </a:pPr>
-            <a:r>
-              <a:rPr kumimoji="0" lang="fr-FR" altLang="fr-FR" sz="1800" b="0" i="0" u="none" strike="noStrike" cap="none" normalizeH="0" baseline="0" dirty="0">
-                <a:ln>
-                  <a:noFill/>
-                </a:ln>
-                <a:solidFill>
-                  <a:schemeClr val="tx1"/>
-                </a:solidFill>
-                <a:effectLst/>
-                <a:latin typeface="Times New Roman" panose="02020603050405020304" pitchFamily="18" charset="0"/>
-                <a:cs typeface="Times New Roman" panose="02020603050405020304" pitchFamily="18" charset="0"/>
-              </a:rPr>
-              <a:t>.Correction des </a:t>
-            </a:r>
-            <a:r>
-              <a:rPr lang="fr-FR" altLang="fr-FR" sz="1800" dirty="0">
-                <a:latin typeface="Times New Roman" panose="02020603050405020304" pitchFamily="18" charset="0"/>
-                <a:cs typeface="Times New Roman" panose="02020603050405020304" pitchFamily="18" charset="0"/>
-              </a:rPr>
-              <a:t>Liens HTML</a:t>
-            </a:r>
-            <a:endParaRPr kumimoji="0" lang="fr-FR" altLang="fr-FR" sz="1800" b="0" i="0" u="none" strike="noStrike" cap="none" normalizeH="0" baseline="0" dirty="0">
-              <a:ln>
-                <a:noFill/>
-              </a:ln>
-              <a:solidFill>
-                <a:schemeClr val="tx1"/>
-              </a:solidFill>
-              <a:effectLst/>
-              <a:latin typeface="Times New Roman" panose="02020603050405020304" pitchFamily="18" charset="0"/>
-              <a:cs typeface="Times New Roman" panose="02020603050405020304" pitchFamily="18" charset="0"/>
-            </a:endParaRPr>
-          </a:p>
-          <a:p>
-            <a:pPr marL="0" marR="0" lvl="0" indent="0" algn="just" defTabSz="914400" rtl="0" eaLnBrk="0" fontAlgn="base" latinLnBrk="0" hangingPunct="0">
-              <a:lnSpc>
-                <a:spcPct val="100000"/>
-              </a:lnSpc>
-              <a:spcBef>
-                <a:spcPct val="0"/>
-              </a:spcBef>
-              <a:spcAft>
-                <a:spcPct val="0"/>
-              </a:spcAft>
-              <a:buClrTx/>
-              <a:buSzTx/>
-              <a:buNone/>
-              <a:tabLst/>
-            </a:pPr>
-            <a:endParaRPr kumimoji="0" lang="fr-FR" altLang="fr-FR" sz="1800" b="0" i="0" u="none" strike="noStrike" cap="none" normalizeH="0" baseline="0" dirty="0">
-              <a:ln>
-                <a:noFill/>
-              </a:ln>
-              <a:solidFill>
-                <a:schemeClr val="tx1"/>
-              </a:solidFill>
-              <a:effectLst/>
-              <a:latin typeface="Times New Roman" panose="02020603050405020304" pitchFamily="18" charset="0"/>
-              <a:cs typeface="Times New Roman" panose="02020603050405020304" pitchFamily="18" charset="0"/>
-            </a:endParaRPr>
-          </a:p>
-          <a:p>
-            <a:pPr marL="0" marR="0" lvl="0" indent="0" algn="just" defTabSz="914400" rtl="0" eaLnBrk="0" fontAlgn="base" latinLnBrk="0" hangingPunct="0">
-              <a:lnSpc>
-                <a:spcPct val="100000"/>
-              </a:lnSpc>
-              <a:spcBef>
-                <a:spcPct val="0"/>
-              </a:spcBef>
-              <a:spcAft>
-                <a:spcPct val="0"/>
-              </a:spcAft>
-              <a:buClrTx/>
-              <a:buSzTx/>
-              <a:buNone/>
-              <a:tabLst/>
-            </a:pPr>
-            <a:endParaRPr kumimoji="0" lang="fr-FR" altLang="fr-FR" sz="1800" b="0" i="0" u="none" strike="noStrike" cap="none" normalizeH="0" baseline="0" dirty="0">
-              <a:ln>
-                <a:noFill/>
-              </a:ln>
-              <a:solidFill>
-                <a:schemeClr val="tx1"/>
-              </a:solidFill>
-              <a:effectLst/>
-              <a:latin typeface="Times New Roman" panose="02020603050405020304" pitchFamily="18" charset="0"/>
-              <a:cs typeface="Times New Roman" panose="02020603050405020304" pitchFamily="18" charset="0"/>
-            </a:endParaRPr>
+            <a:r>
+              <a:rPr lang="fr-FR" dirty="0"/>
+              <a:t>Bootstrap a permis de créer rapidement une interface responsive et moderne.</a:t>
+            </a:r>
+          </a:p>
+          <a:p>
+            <a:r>
+              <a:rPr lang="fr-FR" b="1" dirty="0"/>
+              <a:t>Composants utilisés :</a:t>
+            </a:r>
+            <a:endParaRPr lang="fr-FR" dirty="0"/>
+          </a:p>
+          <a:p>
+            <a:r>
+              <a:rPr lang="fr-FR" b="1" dirty="0"/>
+              <a:t>Navbar</a:t>
+            </a:r>
+            <a:r>
+              <a:rPr lang="fr-FR" dirty="0"/>
+              <a:t> → barre de navigation adaptative mobile/ordinateur.</a:t>
+            </a:r>
+          </a:p>
+          <a:p>
+            <a:r>
+              <a:rPr lang="fr-FR" dirty="0"/>
+              <a:t> </a:t>
+            </a:r>
+            <a:r>
+              <a:rPr lang="fr-FR" b="1" dirty="0"/>
+              <a:t>Cards</a:t>
+            </a:r>
+            <a:r>
+              <a:rPr lang="fr-FR" dirty="0"/>
+              <a:t> → présentation des services et catégories.</a:t>
+            </a:r>
+          </a:p>
+          <a:p>
+            <a:r>
+              <a:rPr lang="fr-FR" dirty="0"/>
+              <a:t> </a:t>
+            </a:r>
+            <a:r>
+              <a:rPr lang="fr-FR" b="1" dirty="0"/>
+              <a:t>Carousel</a:t>
+            </a:r>
+            <a:r>
+              <a:rPr lang="fr-FR" dirty="0"/>
+              <a:t> → affichage dynamique des témoignages clients.</a:t>
+            </a:r>
+          </a:p>
+          <a:p>
+            <a:r>
+              <a:rPr lang="fr-FR" b="1" dirty="0"/>
+              <a:t>Buttons</a:t>
+            </a:r>
+            <a:r>
+              <a:rPr lang="fr-FR" dirty="0"/>
+              <a:t> → création de boutons avec design uniforme.</a:t>
+            </a:r>
+          </a:p>
+          <a:p>
+            <a:r>
+              <a:rPr lang="fr-FR" dirty="0"/>
+              <a:t> </a:t>
+            </a:r>
+            <a:r>
+              <a:rPr lang="fr-FR" b="1" dirty="0"/>
+              <a:t>Grid System</a:t>
+            </a:r>
+            <a:r>
+              <a:rPr lang="fr-FR" dirty="0"/>
+              <a:t> → disposition des éléments en colonnes responsives</a:t>
+            </a:r>
+          </a:p>
+          <a:p>
+            <a:r>
+              <a:rPr lang="fr-FR" dirty="0"/>
+              <a:t> </a:t>
+            </a:r>
+            <a:br>
+              <a:rPr lang="fr-FR" dirty="0"/>
+            </a:br>
+            <a:endParaRPr lang="fr-FR" dirty="0"/>
           </a:p>
         </p:txBody>
       </p:sp>
     </p:spTree>
     <p:extLst>
       <p:ext uri="{BB962C8B-B14F-4D97-AF65-F5344CB8AC3E}">
-        <p14:creationId xmlns:p14="http://schemas.microsoft.com/office/powerpoint/2010/main" val="2298258776"/>
+        <p14:creationId xmlns:p14="http://schemas.microsoft.com/office/powerpoint/2010/main" val="1550318707"/>
       </p:ext>
     </p:extLst>
   </p:cSld>
@@ -6100,7 +7638,7 @@
           <p:cNvPr id="2" name="Titre 1">
             <a:extLst>
               <a:ext uri="{FF2B5EF4-FFF2-40B4-BE49-F238E27FC236}">
-                <a16:creationId xmlns:a16="http://schemas.microsoft.com/office/drawing/2014/main" id="{82FA8760-1091-4653-B14A-97C7A0171642}"/>
+                <a16:creationId xmlns:a16="http://schemas.microsoft.com/office/drawing/2014/main" id="{489B7340-1DB7-44AB-A925-ED1B60748AC3}"/>
               </a:ext>
             </a:extLst>
           </p:cNvPr>
@@ -6120,25 +7658,27 @@
           <a:p>
             <a:pPr algn="ctr"/>
             <a:r>
-              <a:rPr lang="en-US" sz="3600" dirty="0">
-                <a:latin typeface="Arial Black" panose="020B0A04020102020204" pitchFamily="34" charset="0"/>
-              </a:rPr>
-              <a:t>RESOURCES ET DOCUMENTATION</a:t>
+              <a:rPr lang="fr-FR" sz="6000" b="0" i="0" dirty="0">
+                <a:solidFill>
+                  <a:srgbClr val="000000"/>
+                </a:solidFill>
+                <a:effectLst/>
+                <a:latin typeface="Segoe UI Black" panose="020B0A02040204020203" pitchFamily="34" charset="0"/>
+                <a:ea typeface="Segoe UI Black" panose="020B0A02040204020203" pitchFamily="34" charset="0"/>
+              </a:rPr>
+              <a:t>CSS avancé</a:t>
+            </a:r>
+            <a:r>
+              <a:rPr lang="fr-FR" sz="6000" dirty="0">
+                <a:latin typeface="Segoe UI Black" panose="020B0A02040204020203" pitchFamily="34" charset="0"/>
+                <a:ea typeface="Segoe UI Black" panose="020B0A02040204020203" pitchFamily="34" charset="0"/>
+              </a:rPr>
+              <a:t> </a:t>
             </a:r>
             <a:br>
-              <a:rPr lang="en-US" sz="3600" dirty="0">
-                <a:latin typeface="Arial Black" panose="020B0A04020102020204" pitchFamily="34" charset="0"/>
-              </a:rPr>
+              <a:rPr lang="fr-FR" dirty="0"/>
             </a:br>
-            <a:r>
-              <a:rPr lang="en-US" sz="3600" dirty="0">
-                <a:latin typeface="Arial Black" panose="020B0A04020102020204" pitchFamily="34" charset="0"/>
-              </a:rPr>
-              <a:t> UTILISEES</a:t>
-            </a:r>
-            <a:endParaRPr lang="fr-FR" sz="3600" dirty="0">
-              <a:latin typeface="Arial Black" panose="020B0A04020102020204" pitchFamily="34" charset="0"/>
-            </a:endParaRPr>
+            <a:endParaRPr lang="fr-FR" dirty="0"/>
           </a:p>
         </p:txBody>
       </p:sp>
@@ -6147,7 +7687,7 @@
           <p:cNvPr id="3" name="Espace réservé du contenu 2">
             <a:extLst>
               <a:ext uri="{FF2B5EF4-FFF2-40B4-BE49-F238E27FC236}">
-                <a16:creationId xmlns:a16="http://schemas.microsoft.com/office/drawing/2014/main" id="{4794F903-71C8-4BA9-957A-00EE6211EA4E}"/>
+                <a16:creationId xmlns:a16="http://schemas.microsoft.com/office/drawing/2014/main" id="{C6E3390C-8EFE-486E-A16E-59C5A3409377}"/>
               </a:ext>
             </a:extLst>
           </p:cNvPr>
@@ -6160,30 +7700,520 @@
         </p:nvSpPr>
         <p:spPr>
           <a:xfrm>
-            <a:off x="1210279" y="2218932"/>
-            <a:ext cx="9603275" cy="3450613"/>
+            <a:off x="1451579" y="2015732"/>
+            <a:ext cx="10232421" cy="3450613"/>
           </a:xfrm>
         </p:spPr>
         <p:txBody>
-          <a:bodyPr>
-            <a:normAutofit/>
+          <a:bodyPr/>
+          <a:lstStyle/>
+          <a:p>
+            <a:r>
+              <a:rPr lang="fr-FR" b="1" dirty="0"/>
+              <a:t> </a:t>
+            </a:r>
+            <a:r>
+              <a:rPr lang="fr-FR" b="1" dirty="0">
+                <a:solidFill>
+                  <a:schemeClr val="accent1">
+                    <a:lumMod val="60000"/>
+                    <a:lumOff val="40000"/>
+                  </a:schemeClr>
+                </a:solidFill>
+              </a:rPr>
+              <a:t>Variables CSS</a:t>
+            </a:r>
+            <a:br>
+              <a:rPr lang="fr-FR" dirty="0"/>
+            </a:br>
+            <a:r>
+              <a:rPr lang="fr-FR" dirty="0"/>
+              <a:t>Utilisées pour centraliser</a:t>
+            </a:r>
+          </a:p>
+          <a:p>
+            <a:pPr marL="0" indent="0">
+              <a:buNone/>
+            </a:pPr>
+            <a:r>
+              <a:rPr lang="fr-FR" dirty="0"/>
+              <a:t> les couleurs principales du projet.</a:t>
+            </a:r>
+          </a:p>
+          <a:p>
+            <a:pPr marL="0" indent="0">
+              <a:buNone/>
+            </a:pPr>
+            <a:endParaRPr lang="fr-FR" dirty="0"/>
+          </a:p>
+          <a:p>
+            <a:pPr marL="0" indent="0">
+              <a:buNone/>
+            </a:pPr>
+            <a:r>
+              <a:rPr lang="fr-FR" b="1" dirty="0"/>
+              <a:t>. </a:t>
+            </a:r>
+            <a:r>
+              <a:rPr lang="fr-FR" b="1" dirty="0">
+                <a:solidFill>
+                  <a:schemeClr val="accent1">
+                    <a:lumMod val="60000"/>
+                    <a:lumOff val="40000"/>
+                  </a:schemeClr>
+                </a:solidFill>
+              </a:rPr>
+              <a:t>Responsive Design</a:t>
+            </a:r>
+            <a:br>
+              <a:rPr lang="fr-FR" dirty="0"/>
+            </a:br>
+            <a:r>
+              <a:rPr lang="fr-FR" dirty="0"/>
+              <a:t>Permet l’adaptation du site aux petits écrans.</a:t>
+            </a:r>
+          </a:p>
+        </p:txBody>
+      </p:sp>
+      <p:sp>
+        <p:nvSpPr>
+          <p:cNvPr id="4" name="ZoneTexte 3">
+            <a:extLst>
+              <a:ext uri="{FF2B5EF4-FFF2-40B4-BE49-F238E27FC236}">
+                <a16:creationId xmlns:a16="http://schemas.microsoft.com/office/drawing/2014/main" id="{4BB5CBEC-C7D8-4937-9861-19E298D10C93}"/>
+              </a:ext>
+            </a:extLst>
+          </p:cNvPr>
+          <p:cNvSpPr txBox="1"/>
+          <p:nvPr/>
+        </p:nvSpPr>
+        <p:spPr>
+          <a:xfrm>
+            <a:off x="7890934" y="2032878"/>
+            <a:ext cx="2548466" cy="1384995"/>
+          </a:xfrm>
+          <a:prstGeom prst="rect">
+            <a:avLst/>
+          </a:prstGeom>
+          <a:noFill/>
+        </p:spPr>
+        <p:txBody>
+          <a:bodyPr wrap="square" rtlCol="0">
+            <a:spAutoFit/>
           </a:bodyPr>
           <a:lstStyle/>
           <a:p>
             <a:r>
-              <a:rPr lang="fr-FR" sz="2800" dirty="0">
-                <a:latin typeface="Times New Roman" panose="02020603050405020304" pitchFamily="18" charset="0"/>
-                <a:cs typeface="Times New Roman" panose="02020603050405020304" pitchFamily="18" charset="0"/>
-              </a:rPr>
-              <a:t>“Pour réaliser AfriTalent, j’ai utilisé MDN pour apprendre HTML, CSS et JavaScript, Bootstrap pour créer une interface responsive, Google Fonts pour la typographie, GitHub pour gérer les versions, GitHub Pages pour le déploiement et W3C Validator pour vérifier et corriger les erreurs du code.”</a:t>
-            </a:r>
+              <a:rPr lang="en-US" sz="1200" b="0" dirty="0">
+                <a:solidFill>
+                  <a:srgbClr val="9CDCFE"/>
+                </a:solidFill>
+                <a:effectLst/>
+                <a:latin typeface="Consolas" panose="020B0609020204030204" pitchFamily="49" charset="0"/>
+              </a:rPr>
+              <a:t>primary-color</a:t>
+            </a:r>
+            <a:r>
+              <a:rPr lang="en-US" sz="1200" b="0" dirty="0">
+                <a:solidFill>
+                  <a:srgbClr val="BBBEBF"/>
+                </a:solidFill>
+                <a:effectLst/>
+                <a:latin typeface="Consolas" panose="020B0609020204030204" pitchFamily="49" charset="0"/>
+              </a:rPr>
+              <a:t>: </a:t>
+            </a:r>
+            <a:r>
+              <a:rPr lang="en-US" sz="1200" b="0" dirty="0">
+                <a:solidFill>
+                  <a:srgbClr val="CE9178"/>
+                </a:solidFill>
+                <a:effectLst/>
+                <a:latin typeface="Consolas" panose="020B0609020204030204" pitchFamily="49" charset="0"/>
+              </a:rPr>
+              <a:t>#0d6efd</a:t>
+            </a:r>
+            <a:r>
+              <a:rPr lang="en-US" sz="1200" b="0" dirty="0">
+                <a:solidFill>
+                  <a:srgbClr val="BBBEBF"/>
+                </a:solidFill>
+                <a:effectLst/>
+                <a:latin typeface="Consolas" panose="020B0609020204030204" pitchFamily="49" charset="0"/>
+              </a:rPr>
+              <a:t>;</a:t>
+            </a:r>
+          </a:p>
+          <a:p>
+            <a:r>
+              <a:rPr lang="en-US" sz="1200" b="0" dirty="0">
+                <a:solidFill>
+                  <a:srgbClr val="BBBEBF"/>
+                </a:solidFill>
+                <a:effectLst/>
+                <a:latin typeface="Consolas" panose="020B0609020204030204" pitchFamily="49" charset="0"/>
+              </a:rPr>
+              <a:t>    </a:t>
+            </a:r>
+            <a:r>
+              <a:rPr lang="en-US" sz="1200" b="0" dirty="0">
+                <a:solidFill>
+                  <a:srgbClr val="9CDCFE"/>
+                </a:solidFill>
+                <a:effectLst/>
+                <a:latin typeface="Consolas" panose="020B0609020204030204" pitchFamily="49" charset="0"/>
+              </a:rPr>
+              <a:t>--secondary-color</a:t>
+            </a:r>
+            <a:r>
+              <a:rPr lang="en-US" sz="1200" b="0" dirty="0">
+                <a:solidFill>
+                  <a:srgbClr val="BBBEBF"/>
+                </a:solidFill>
+                <a:effectLst/>
+                <a:latin typeface="Consolas" panose="020B0609020204030204" pitchFamily="49" charset="0"/>
+              </a:rPr>
+              <a:t>: </a:t>
+            </a:r>
+            <a:r>
+              <a:rPr lang="en-US" sz="1200" b="0" dirty="0">
+                <a:solidFill>
+                  <a:srgbClr val="CE9178"/>
+                </a:solidFill>
+                <a:effectLst/>
+                <a:latin typeface="Consolas" panose="020B0609020204030204" pitchFamily="49" charset="0"/>
+              </a:rPr>
+              <a:t>#6c757d</a:t>
+            </a:r>
+            <a:r>
+              <a:rPr lang="en-US" sz="1200" b="0" dirty="0">
+                <a:solidFill>
+                  <a:srgbClr val="BBBEBF"/>
+                </a:solidFill>
+                <a:effectLst/>
+                <a:latin typeface="Consolas" panose="020B0609020204030204" pitchFamily="49" charset="0"/>
+              </a:rPr>
+              <a:t>;</a:t>
+            </a:r>
+          </a:p>
+          <a:p>
+            <a:r>
+              <a:rPr lang="en-US" sz="1200" b="0" dirty="0">
+                <a:solidFill>
+                  <a:srgbClr val="BBBEBF"/>
+                </a:solidFill>
+                <a:effectLst/>
+                <a:latin typeface="Consolas" panose="020B0609020204030204" pitchFamily="49" charset="0"/>
+              </a:rPr>
+              <a:t>    </a:t>
+            </a:r>
+            <a:r>
+              <a:rPr lang="en-US" sz="1200" b="0" dirty="0">
+                <a:solidFill>
+                  <a:srgbClr val="9CDCFE"/>
+                </a:solidFill>
+                <a:effectLst/>
+                <a:latin typeface="Consolas" panose="020B0609020204030204" pitchFamily="49" charset="0"/>
+              </a:rPr>
+              <a:t>--accent-color</a:t>
+            </a:r>
+            <a:r>
+              <a:rPr lang="en-US" sz="1200" b="0" dirty="0">
+                <a:solidFill>
+                  <a:srgbClr val="BBBEBF"/>
+                </a:solidFill>
+                <a:effectLst/>
+                <a:latin typeface="Consolas" panose="020B0609020204030204" pitchFamily="49" charset="0"/>
+              </a:rPr>
+              <a:t>: </a:t>
+            </a:r>
+            <a:r>
+              <a:rPr lang="en-US" sz="1200" b="0" dirty="0">
+                <a:solidFill>
+                  <a:srgbClr val="CE9178"/>
+                </a:solidFill>
+                <a:effectLst/>
+                <a:latin typeface="Consolas" panose="020B0609020204030204" pitchFamily="49" charset="0"/>
+              </a:rPr>
+              <a:t>#ffc107</a:t>
+            </a:r>
+            <a:r>
+              <a:rPr lang="en-US" sz="1200" b="0" dirty="0">
+                <a:solidFill>
+                  <a:srgbClr val="BBBEBF"/>
+                </a:solidFill>
+                <a:effectLst/>
+                <a:latin typeface="Consolas" panose="020B0609020204030204" pitchFamily="49" charset="0"/>
+              </a:rPr>
+              <a:t>;</a:t>
+            </a:r>
+          </a:p>
+          <a:p>
+            <a:r>
+              <a:rPr lang="en-US" sz="1200" b="0" dirty="0">
+                <a:solidFill>
+                  <a:srgbClr val="BBBEBF"/>
+                </a:solidFill>
+                <a:effectLst/>
+                <a:latin typeface="Consolas" panose="020B0609020204030204" pitchFamily="49" charset="0"/>
+              </a:rPr>
+              <a:t>    </a:t>
+            </a:r>
+            <a:r>
+              <a:rPr lang="en-US" sz="1200" b="0" dirty="0">
+                <a:solidFill>
+                  <a:srgbClr val="9CDCFE"/>
+                </a:solidFill>
+                <a:effectLst/>
+                <a:latin typeface="Consolas" panose="020B0609020204030204" pitchFamily="49" charset="0"/>
+              </a:rPr>
+              <a:t>--dark-color</a:t>
+            </a:r>
+            <a:r>
+              <a:rPr lang="en-US" sz="1200" b="0" dirty="0">
+                <a:solidFill>
+                  <a:srgbClr val="BBBEBF"/>
+                </a:solidFill>
+                <a:effectLst/>
+                <a:latin typeface="Consolas" panose="020B0609020204030204" pitchFamily="49" charset="0"/>
+              </a:rPr>
+              <a:t>: </a:t>
+            </a:r>
+            <a:r>
+              <a:rPr lang="en-US" sz="1200" b="0" dirty="0">
+                <a:solidFill>
+                  <a:srgbClr val="CE9178"/>
+                </a:solidFill>
+                <a:effectLst/>
+                <a:latin typeface="Consolas" panose="020B0609020204030204" pitchFamily="49" charset="0"/>
+              </a:rPr>
+              <a:t>#212529</a:t>
+            </a:r>
+            <a:r>
+              <a:rPr lang="en-US" sz="1200" b="0" dirty="0">
+                <a:solidFill>
+                  <a:srgbClr val="BBBEBF"/>
+                </a:solidFill>
+                <a:effectLst/>
+                <a:latin typeface="Consolas" panose="020B0609020204030204" pitchFamily="49" charset="0"/>
+              </a:rPr>
+              <a:t>;</a:t>
+            </a:r>
+          </a:p>
+          <a:p>
+            <a:r>
+              <a:rPr lang="en-US" sz="1200" b="0" dirty="0">
+                <a:solidFill>
+                  <a:srgbClr val="BBBEBF"/>
+                </a:solidFill>
+                <a:effectLst/>
+                <a:latin typeface="Consolas" panose="020B0609020204030204" pitchFamily="49" charset="0"/>
+              </a:rPr>
+              <a:t>    </a:t>
+            </a:r>
+            <a:r>
+              <a:rPr lang="en-US" sz="1200" b="0" dirty="0">
+                <a:solidFill>
+                  <a:srgbClr val="9CDCFE"/>
+                </a:solidFill>
+                <a:effectLst/>
+                <a:latin typeface="Consolas" panose="020B0609020204030204" pitchFamily="49" charset="0"/>
+              </a:rPr>
+              <a:t>--light-color</a:t>
+            </a:r>
+            <a:r>
+              <a:rPr lang="en-US" sz="1200" b="0" dirty="0">
+                <a:solidFill>
+                  <a:srgbClr val="BBBEBF"/>
+                </a:solidFill>
+                <a:effectLst/>
+                <a:latin typeface="Consolas" panose="020B0609020204030204" pitchFamily="49" charset="0"/>
+              </a:rPr>
+              <a:t>: </a:t>
+            </a:r>
+            <a:r>
+              <a:rPr lang="en-US" sz="1200" b="0" dirty="0">
+                <a:solidFill>
+                  <a:srgbClr val="CE9178"/>
+                </a:solidFill>
+                <a:effectLst/>
+                <a:latin typeface="Consolas" panose="020B0609020204030204" pitchFamily="49" charset="0"/>
+              </a:rPr>
+              <a:t>#f8f9fa</a:t>
+            </a:r>
+            <a:r>
+              <a:rPr lang="en-US" sz="1200" b="0" dirty="0">
+                <a:solidFill>
+                  <a:srgbClr val="BBBEBF"/>
+                </a:solidFill>
+                <a:effectLst/>
+                <a:latin typeface="Consolas" panose="020B0609020204030204" pitchFamily="49" charset="0"/>
+              </a:rPr>
+              <a:t>;</a:t>
+            </a:r>
+          </a:p>
+          <a:p>
+            <a:r>
+              <a:rPr lang="en-US" sz="1200" b="0" dirty="0">
+                <a:solidFill>
+                  <a:srgbClr val="BBBEBF"/>
+                </a:solidFill>
+                <a:effectLst/>
+                <a:latin typeface="Consolas" panose="020B0609020204030204" pitchFamily="49" charset="0"/>
+              </a:rPr>
+              <a:t>    </a:t>
+            </a:r>
+            <a:r>
+              <a:rPr lang="en-US" sz="1200" b="0" dirty="0">
+                <a:solidFill>
+                  <a:srgbClr val="9CDCFE"/>
+                </a:solidFill>
+                <a:effectLst/>
+                <a:latin typeface="Consolas" panose="020B0609020204030204" pitchFamily="49" charset="0"/>
+              </a:rPr>
+              <a:t>--white-color</a:t>
+            </a:r>
+            <a:r>
+              <a:rPr lang="en-US" sz="1200" b="0" dirty="0">
+                <a:solidFill>
+                  <a:srgbClr val="BBBEBF"/>
+                </a:solidFill>
+                <a:effectLst/>
+                <a:latin typeface="Consolas" panose="020B0609020204030204" pitchFamily="49" charset="0"/>
+              </a:rPr>
+              <a:t>: </a:t>
+            </a:r>
+            <a:r>
+              <a:rPr lang="en-US" sz="1200" b="0" dirty="0">
+                <a:solidFill>
+                  <a:srgbClr val="CE9178"/>
+                </a:solidFill>
+                <a:effectLst/>
+                <a:latin typeface="Consolas" panose="020B0609020204030204" pitchFamily="49" charset="0"/>
+              </a:rPr>
+              <a:t>#ffffff</a:t>
+            </a:r>
+            <a:r>
+              <a:rPr lang="en-US" sz="1200" b="0" dirty="0">
+                <a:solidFill>
+                  <a:srgbClr val="BBBEBF"/>
+                </a:solidFill>
+                <a:effectLst/>
+                <a:latin typeface="Consolas" panose="020B0609020204030204" pitchFamily="49" charset="0"/>
+              </a:rPr>
+              <a:t>;</a:t>
+            </a:r>
+          </a:p>
+        </p:txBody>
+      </p:sp>
+      <p:sp>
+        <p:nvSpPr>
+          <p:cNvPr id="8" name="ZoneTexte 7">
+            <a:extLst>
+              <a:ext uri="{FF2B5EF4-FFF2-40B4-BE49-F238E27FC236}">
+                <a16:creationId xmlns:a16="http://schemas.microsoft.com/office/drawing/2014/main" id="{EFF4DBA3-F009-43E9-9F63-02A3437A5FAB}"/>
+              </a:ext>
+            </a:extLst>
+          </p:cNvPr>
+          <p:cNvSpPr txBox="1"/>
+          <p:nvPr/>
+        </p:nvSpPr>
+        <p:spPr>
+          <a:xfrm>
+            <a:off x="6858000" y="4483099"/>
+            <a:ext cx="4461933" cy="646331"/>
+          </a:xfrm>
+          <a:prstGeom prst="rect">
+            <a:avLst/>
+          </a:prstGeom>
+          <a:noFill/>
+        </p:spPr>
+        <p:txBody>
+          <a:bodyPr wrap="square" rtlCol="0">
+            <a:spAutoFit/>
+          </a:bodyPr>
+          <a:lstStyle/>
+          <a:p>
+            <a:r>
+              <a:rPr lang="fr-FR" b="0" dirty="0">
+                <a:solidFill>
+                  <a:srgbClr val="C586C0"/>
+                </a:solidFill>
+                <a:effectLst/>
+                <a:latin typeface="Consolas" panose="020B0609020204030204" pitchFamily="49" charset="0"/>
+              </a:rPr>
+              <a:t>@media</a:t>
+            </a:r>
+            <a:r>
+              <a:rPr lang="fr-FR" b="0" dirty="0">
+                <a:solidFill>
+                  <a:srgbClr val="BBBEBF"/>
+                </a:solidFill>
+                <a:effectLst/>
+                <a:latin typeface="Consolas" panose="020B0609020204030204" pitchFamily="49" charset="0"/>
+              </a:rPr>
+              <a:t> (</a:t>
+            </a:r>
+            <a:r>
+              <a:rPr lang="fr-FR" b="0" dirty="0">
+                <a:solidFill>
+                  <a:srgbClr val="9CDCFE"/>
+                </a:solidFill>
+                <a:effectLst/>
+                <a:latin typeface="Consolas" panose="020B0609020204030204" pitchFamily="49" charset="0"/>
+              </a:rPr>
+              <a:t>min-</a:t>
+            </a:r>
+            <a:r>
+              <a:rPr lang="fr-FR" b="0" dirty="0" err="1">
+                <a:solidFill>
+                  <a:srgbClr val="9CDCFE"/>
+                </a:solidFill>
+                <a:effectLst/>
+                <a:latin typeface="Consolas" panose="020B0609020204030204" pitchFamily="49" charset="0"/>
+              </a:rPr>
+              <a:t>width</a:t>
+            </a:r>
+            <a:r>
+              <a:rPr lang="fr-FR" b="0" dirty="0">
+                <a:solidFill>
+                  <a:srgbClr val="BBBEBF"/>
+                </a:solidFill>
+                <a:effectLst/>
+                <a:latin typeface="Consolas" panose="020B0609020204030204" pitchFamily="49" charset="0"/>
+              </a:rPr>
+              <a:t>: </a:t>
+            </a:r>
+            <a:r>
+              <a:rPr lang="fr-FR" b="0" dirty="0">
+                <a:solidFill>
+                  <a:srgbClr val="B5CEA8"/>
+                </a:solidFill>
+                <a:effectLst/>
+                <a:latin typeface="Consolas" panose="020B0609020204030204" pitchFamily="49" charset="0"/>
+              </a:rPr>
+              <a:t>768px</a:t>
+            </a:r>
+            <a:r>
+              <a:rPr lang="fr-FR" b="0" dirty="0">
+                <a:solidFill>
+                  <a:srgbClr val="BBBEBF"/>
+                </a:solidFill>
+                <a:effectLst/>
+                <a:latin typeface="Consolas" panose="020B0609020204030204" pitchFamily="49" charset="0"/>
+              </a:rPr>
+              <a:t>)</a:t>
+            </a:r>
+          </a:p>
+          <a:p>
+            <a:endParaRPr lang="fr-FR" dirty="0"/>
           </a:p>
         </p:txBody>
       </p:sp>
     </p:spTree>
     <p:extLst>
       <p:ext uri="{BB962C8B-B14F-4D97-AF65-F5344CB8AC3E}">
-        <p14:creationId xmlns:p14="http://schemas.microsoft.com/office/powerpoint/2010/main" val="263038865"/>
+        <p14:creationId xmlns:p14="http://schemas.microsoft.com/office/powerpoint/2010/main" val="2616116430"/>
       </p:ext>
     </p:extLst>
   </p:cSld>

</xml_diff>